<commit_message>
Week 7 L2 slide 4: calibration = intrinsics + extrinsics; the demo shows an extrinsic error
Co-Authored-By: Claude Opus 5.5 <noreply@anthropic.com>
</commit_message>
<xml_diff>
--- a/第七週(10-22)/第七週_第2節_簡報.pptx
+++ b/第七週(10-22)/第七週_第2節_簡報.pptx
@@ -2409,7 +2409,7 @@
                 <a:ea typeface="Arial Unicode MS"/>
                 <a:cs typeface="Arial Unicode MS"/>
               </a:rPr>
-              <a:t>標定</a:t>
+              <a:t>外參標定</a:t>
             </a:r>
             <a:r>
               <a:rPr sz="850" lang="zh-TW" dirty="0">
@@ -2420,7 +2420,7 @@
                 <a:ea typeface="Arial Unicode MS"/>
                 <a:cs typeface="Arial Unicode MS"/>
               </a:rPr>
-              <a:t>，量出來的六個數字叫外參。第四張那兩張圖看過：光達只要多轉四度，點就從那台廂型車上整片滑到旁邊的樹上。真的車不會差到四度，可是差一度，五十公尺外就差將近一公尺，快半個車道。
+              <a:t>，量出來的六個數字叫外參；鏡頭自己有多彎，是內參，第五週講過。第四張那兩張圖看過：光達只要多轉四度，點就從那台廂型車上整片滑到旁邊的樹上。真的車不會差到四度，可是差一度，五十公尺外就差將近一公尺，快半個車道。
 </a:t>
             </a:r>
           </a:p>
@@ -3838,11 +3838,11 @@
                 <a:spcPts val="0"/>
               </a:spcBef>
               <a:spcAft>
-                <a:spcPts val="150"/>
+                <a:spcPts val="133"/>
               </a:spcAft>
             </a:pPr>
             <a:r>
-              <a:rPr sz="900" b="1" lang="zh-TW" dirty="0">
+              <a:rPr sz="800" b="1" lang="zh-TW" dirty="0">
                 <a:solidFill>
                   <a:srgbClr val="000000"/>
                 </a:solidFill>
@@ -3853,7 +3853,7 @@
               <a:t>這一張的目的：</a:t>
             </a:r>
             <a:r>
-              <a:rPr sz="900" lang="zh-TW" dirty="0">
+              <a:rPr sz="800" lang="zh-TW" dirty="0">
                 <a:solidFill>
                   <a:srgbClr val="000000"/>
                 </a:solidFill>
@@ -3871,11 +3871,11 @@
                 <a:spcPts val="0"/>
               </a:spcBef>
               <a:spcAft>
-                <a:spcPts val="150"/>
+                <a:spcPts val="133"/>
               </a:spcAft>
             </a:pPr>
             <a:r>
-              <a:rPr sz="900" lang="zh-TW" dirty="0">
+              <a:rPr sz="800" lang="zh-TW" dirty="0">
                 <a:solidFill>
                   <a:srgbClr val="000000"/>
                 </a:solidFill>
@@ -3886,7 +3886,7 @@
               <a:t>要合起來，第一件事：</a:t>
             </a:r>
             <a:r>
-              <a:rPr sz="900" b="1" lang="zh-TW" dirty="0">
+              <a:rPr sz="800" b="1" lang="zh-TW" dirty="0">
                 <a:solidFill>
                   <a:srgbClr val="000000"/>
                 </a:solidFill>
@@ -3897,7 +3897,7 @@
               <a:t>大家要對齊同一個空間。</a:t>
             </a:r>
             <a:r>
-              <a:rPr sz="900" lang="zh-TW" dirty="0">
+              <a:rPr sz="800" lang="zh-TW" dirty="0">
                 <a:solidFill>
                   <a:srgbClr val="000000"/>
                 </a:solidFill>
@@ -3915,11 +3915,11 @@
                 <a:spcPts val="0"/>
               </a:spcBef>
               <a:spcAft>
-                <a:spcPts val="150"/>
+                <a:spcPts val="133"/>
               </a:spcAft>
             </a:pPr>
             <a:r>
-              <a:rPr sz="900" lang="zh-TW" dirty="0">
+              <a:rPr sz="800" lang="zh-TW" dirty="0">
                 <a:solidFill>
                   <a:srgbClr val="000000"/>
                 </a:solidFill>
@@ -3930,7 +3930,7 @@
               <a:t>先想一個教室裡的例子。三個同學坐在不同的位置、臉朝不同的方向。老師問：「垃圾桶在哪裡？」坐前排、面向黑板的同學說：「在我右前方兩公尺。」坐後排、面向窗戶的同學說：「在我正前方五公尺。」兩個人都沒說錯，可是你沒辦法把這兩句話直接畫在同一張教室平面圖上。你得先知道：</a:t>
             </a:r>
             <a:r>
-              <a:rPr sz="900" b="1" lang="zh-TW" dirty="0">
+              <a:rPr sz="800" b="1" lang="zh-TW" dirty="0">
                 <a:solidFill>
                   <a:srgbClr val="000000"/>
                 </a:solidFill>
@@ -3941,7 +3941,7 @@
               <a:t>每個人坐在哪一個座位、臉朝哪個方向。</a:t>
             </a:r>
             <a:r>
-              <a:rPr sz="900" lang="zh-TW" dirty="0">
+              <a:rPr sz="800" lang="zh-TW" dirty="0">
                 <a:solidFill>
                   <a:srgbClr val="000000"/>
                 </a:solidFill>
@@ -3959,11 +3959,11 @@
                 <a:spcPts val="0"/>
               </a:spcBef>
               <a:spcAft>
-                <a:spcPts val="150"/>
+                <a:spcPts val="133"/>
               </a:spcAft>
             </a:pPr>
             <a:r>
-              <a:rPr sz="900" lang="zh-TW" dirty="0">
+              <a:rPr sz="800" lang="zh-TW" dirty="0">
                 <a:solidFill>
                   <a:srgbClr val="000000"/>
                 </a:solidFill>
@@ -3974,7 +3974,7 @@
               <a:t>車上完全一樣。相機在擋風玻璃後面，光達在車頂，雷達在保險桿。每一顆回報的，都是「東西在</a:t>
             </a:r>
             <a:r>
-              <a:rPr sz="900" b="1" lang="zh-TW" dirty="0">
+              <a:rPr sz="800" b="1" lang="zh-TW" dirty="0">
                 <a:solidFill>
                   <a:srgbClr val="000000"/>
                 </a:solidFill>
@@ -3985,7 +3985,7 @@
               <a:t>我</a:t>
             </a:r>
             <a:r>
-              <a:rPr sz="900" lang="zh-TW" dirty="0">
+              <a:rPr sz="800" lang="zh-TW" dirty="0">
                 <a:solidFill>
                   <a:srgbClr val="000000"/>
                 </a:solidFill>
@@ -3996,7 +3996,7 @@
               <a:t>的哪個方向、離</a:t>
             </a:r>
             <a:r>
-              <a:rPr sz="900" b="1" lang="zh-TW" dirty="0">
+              <a:rPr sz="800" b="1" lang="zh-TW" dirty="0">
                 <a:solidFill>
                   <a:srgbClr val="000000"/>
                 </a:solidFill>
@@ -4007,7 +4007,7 @@
               <a:t>我</a:t>
             </a:r>
             <a:r>
-              <a:rPr sz="900" lang="zh-TW" dirty="0">
+              <a:rPr sz="800" lang="zh-TW" dirty="0">
                 <a:solidFill>
                   <a:srgbClr val="000000"/>
                 </a:solidFill>
@@ -4018,7 +4018,7 @@
               <a:t>多遠」。要合起來，得先知道每一顆</a:t>
             </a:r>
             <a:r>
-              <a:rPr sz="900" b="1" lang="zh-TW" dirty="0">
+              <a:rPr sz="800" b="1" lang="zh-TW" dirty="0">
                 <a:solidFill>
                   <a:srgbClr val="000000"/>
                 </a:solidFill>
@@ -4029,7 +4029,7 @@
               <a:t>裝在車上的哪裡、朝哪個方向</a:t>
             </a:r>
             <a:r>
-              <a:rPr sz="900" lang="zh-TW" dirty="0">
+              <a:rPr sz="800" lang="zh-TW" dirty="0">
                 <a:solidFill>
                   <a:srgbClr val="000000"/>
                 </a:solidFill>
@@ -4040,7 +4040,7 @@
               <a:t>。這組數字就叫</a:t>
             </a:r>
             <a:r>
-              <a:rPr sz="900" b="1" lang="zh-TW" dirty="0">
+              <a:rPr sz="800" b="1" lang="zh-TW" dirty="0">
                 <a:solidFill>
                   <a:srgbClr val="000000"/>
                 </a:solidFill>
@@ -4051,7 +4051,7 @@
               <a:t>外參</a:t>
             </a:r>
             <a:r>
-              <a:rPr sz="900" lang="zh-TW" dirty="0">
+              <a:rPr sz="800" lang="zh-TW" dirty="0">
                 <a:solidFill>
                   <a:srgbClr val="000000"/>
                 </a:solidFill>
@@ -4062,7 +4062,7 @@
               <a:t>，第五週講過：它是對</a:t>
             </a:r>
             <a:r>
-              <a:rPr sz="900" b="1" lang="zh-TW" dirty="0">
+              <a:rPr sz="800" b="1" lang="zh-TW" dirty="0">
                 <a:solidFill>
                   <a:srgbClr val="000000"/>
                 </a:solidFill>
@@ -4073,7 +4073,7 @@
               <a:t>車身</a:t>
             </a:r>
             <a:r>
-              <a:rPr sz="900" lang="zh-TW" dirty="0">
+              <a:rPr sz="800" lang="zh-TW" dirty="0">
                 <a:solidFill>
                   <a:srgbClr val="000000"/>
                 </a:solidFill>
@@ -4084,7 +4084,7 @@
               <a:t>量的，不是對另一顆感測器。量出這組數字的工作，叫</a:t>
             </a:r>
             <a:r>
-              <a:rPr sz="900" b="1" lang="zh-TW" dirty="0">
+              <a:rPr sz="800" b="1" lang="zh-TW" dirty="0">
                 <a:solidFill>
                   <a:srgbClr val="000000"/>
                 </a:solidFill>
@@ -4095,7 +4095,7 @@
               <a:t>外參標定</a:t>
             </a:r>
             <a:r>
-              <a:rPr sz="900" lang="zh-TW" dirty="0">
+              <a:rPr sz="800" lang="zh-TW" dirty="0">
                 <a:solidFill>
                   <a:srgbClr val="000000"/>
                 </a:solidFill>
@@ -4113,41 +4113,107 @@
                 <a:spcPts val="0"/>
               </a:spcBef>
               <a:spcAft>
-                <a:spcPts val="150"/>
+                <a:spcPts val="133"/>
               </a:spcAft>
             </a:pPr>
             <a:r>
-              <a:rPr sz="900" lang="zh-TW" dirty="0">
-                <a:solidFill>
-                  <a:srgbClr val="000000"/>
-                </a:solidFill>
-                <a:latin typeface="Arial Unicode MS"/>
-                <a:ea typeface="Arial Unicode MS"/>
-                <a:cs typeface="Arial Unicode MS"/>
-              </a:rPr>
-              <a:t>外參到底是什麼？就是每一顆六個數字。位置三個：往前多少、往左多少、離地多高。方向三個：左右轉了幾度、上下仰了幾度、有沒有歪向一邊。nuScenes 每一顆感測器都附了這六個數字，舉幾個真的：前方相機裝在後輪軸往前一點七公尺、離地一點五公尺；光達在後輪軸往前零點九公尺、離地一點八公尺；前雷達在最前面，往前三點四公尺、離地零點五公尺；左前角那顆雷達，往前二點四公尺、往左零點八公尺，而且它是</a:t>
-            </a:r>
-            <a:r>
-              <a:rPr sz="900" b="1" lang="zh-TW" dirty="0">
-                <a:solidFill>
-                  <a:srgbClr val="000000"/>
-                </a:solidFill>
-                <a:latin typeface="Arial Unicode MS"/>
-                <a:ea typeface="Arial Unicode MS"/>
-                <a:cs typeface="Arial Unicode MS"/>
-              </a:rPr>
-              <a:t>朝左邊</a:t>
-            </a:r>
-            <a:r>
-              <a:rPr sz="900" lang="zh-TW" dirty="0">
-                <a:solidFill>
-                  <a:srgbClr val="000000"/>
-                </a:solidFill>
-                <a:latin typeface="Arial Unicode MS"/>
-                <a:ea typeface="Arial Unicode MS"/>
-                <a:cs typeface="Arial Unicode MS"/>
-              </a:rPr>
-              <a:t>裝的。
+              <a:rPr sz="800" lang="zh-TW" dirty="0">
+                <a:solidFill>
+                  <a:srgbClr val="000000"/>
+                </a:solidFill>
+                <a:latin typeface="Arial Unicode MS"/>
+                <a:ea typeface="Arial Unicode MS"/>
+                <a:cs typeface="Arial Unicode MS"/>
+              </a:rPr>
+              <a:t>這裡要分清楚：</a:t>
+            </a:r>
+            <a:r>
+              <a:rPr sz="800" b="1" lang="zh-TW" dirty="0">
+                <a:solidFill>
+                  <a:srgbClr val="000000"/>
+                </a:solidFill>
+                <a:latin typeface="Arial Unicode MS"/>
+                <a:ea typeface="Arial Unicode MS"/>
+                <a:cs typeface="Arial Unicode MS"/>
+              </a:rPr>
+              <a:t>標定不只有外參。</a:t>
+            </a:r>
+            <a:r>
+              <a:rPr sz="800" lang="zh-TW" dirty="0">
+                <a:solidFill>
+                  <a:srgbClr val="000000"/>
+                </a:solidFill>
+                <a:latin typeface="Arial Unicode MS"/>
+                <a:ea typeface="Arial Unicode MS"/>
+                <a:cs typeface="Arial Unicode MS"/>
+              </a:rPr>
+              <a:t>第五週講過，標定分兩種，而且有先後。</a:t>
+            </a:r>
+            <a:r>
+              <a:rPr sz="800" b="1" lang="zh-TW" dirty="0">
+                <a:solidFill>
+                  <a:srgbClr val="000000"/>
+                </a:solidFill>
+                <a:latin typeface="Arial Unicode MS"/>
+                <a:ea typeface="Arial Unicode MS"/>
+                <a:cs typeface="Arial Unicode MS"/>
+              </a:rPr>
+              <a:t>內參</a:t>
+            </a:r>
+            <a:r>
+              <a:rPr sz="800" lang="zh-TW" dirty="0">
+                <a:solidFill>
+                  <a:srgbClr val="000000"/>
+                </a:solidFill>
+                <a:latin typeface="Arial Unicode MS"/>
+                <a:ea typeface="Arial Unicode MS"/>
+                <a:cs typeface="Arial Unicode MS"/>
+              </a:rPr>
+              <a:t>是感測器自己內部的事：相機的鏡頭有多彎、畫面正中心在哪一個像素；光達每一條雷射線真正往上或往下幾度。</a:t>
+            </a:r>
+            <a:r>
+              <a:rPr sz="800" b="1" lang="zh-TW" dirty="0">
+                <a:solidFill>
+                  <a:srgbClr val="000000"/>
+                </a:solidFill>
+                <a:latin typeface="Arial Unicode MS"/>
+                <a:ea typeface="Arial Unicode MS"/>
+                <a:cs typeface="Arial Unicode MS"/>
+              </a:rPr>
+              <a:t>外參</a:t>
+            </a:r>
+            <a:r>
+              <a:rPr sz="800" lang="zh-TW" dirty="0">
+                <a:solidFill>
+                  <a:srgbClr val="000000"/>
+                </a:solidFill>
+                <a:latin typeface="Arial Unicode MS"/>
+                <a:ea typeface="Arial Unicode MS"/>
+                <a:cs typeface="Arial Unicode MS"/>
+              </a:rPr>
+              <a:t>才是它裝在車上的哪裡、朝哪個方向。先標內參，再標外參。把光達點畫到照片上，兩個都要用：先用外參，把點從光達的位置換到相機的位置；再用內參，算出它落在照片的哪一個像素。今天這兩張圖示範的是</a:t>
+            </a:r>
+            <a:r>
+              <a:rPr sz="800" b="1" lang="zh-TW" dirty="0">
+                <a:solidFill>
+                  <a:srgbClr val="000000"/>
+                </a:solidFill>
+                <a:latin typeface="Arial Unicode MS"/>
+                <a:ea typeface="Arial Unicode MS"/>
+                <a:cs typeface="Arial Unicode MS"/>
+              </a:rPr>
+              <a:t>外參</a:t>
+            </a:r>
+            <a:r>
+              <a:rPr sz="800" lang="zh-TW" dirty="0">
+                <a:solidFill>
+                  <a:srgbClr val="000000"/>
+                </a:solidFill>
+                <a:latin typeface="Arial Unicode MS"/>
+                <a:ea typeface="Arial Unicode MS"/>
+                <a:cs typeface="Arial Unicode MS"/>
+              </a:rPr>
+              <a:t>出錯：鏡頭沒問題，是光達的方向多轉了四度。
 </a:t>
             </a:r>
           </a:p>
@@ -4157,41 +4223,41 @@
                 <a:spcPts val="0"/>
               </a:spcBef>
               <a:spcAft>
-                <a:spcPts val="150"/>
+                <a:spcPts val="133"/>
               </a:spcAft>
             </a:pPr>
             <a:r>
-              <a:rPr sz="900" lang="zh-TW" dirty="0">
-                <a:solidFill>
-                  <a:srgbClr val="000000"/>
-                </a:solidFill>
-                <a:latin typeface="Arial Unicode MS"/>
-                <a:ea typeface="Arial Unicode MS"/>
-                <a:cs typeface="Arial Unicode MS"/>
-              </a:rPr>
-              <a:t>方向特別要緊。nuScenes 這顆光達，它自己的「正前方」，其實是朝</a:t>
-            </a:r>
-            <a:r>
-              <a:rPr sz="900" b="1" lang="zh-TW" dirty="0">
-                <a:solidFill>
-                  <a:srgbClr val="000000"/>
-                </a:solidFill>
-                <a:latin typeface="Arial Unicode MS"/>
-                <a:ea typeface="Arial Unicode MS"/>
-                <a:cs typeface="Arial Unicode MS"/>
-              </a:rPr>
-              <a:t>車子的右邊</a:t>
-            </a:r>
-            <a:r>
-              <a:rPr sz="900" lang="zh-TW" dirty="0">
-                <a:solidFill>
-                  <a:srgbClr val="000000"/>
-                </a:solidFill>
-                <a:latin typeface="Arial Unicode MS"/>
-                <a:ea typeface="Arial Unicode MS"/>
-                <a:cs typeface="Arial Unicode MS"/>
-              </a:rPr>
-              <a:t>裝的，轉了九十度。如果不知道這件事，光達說「我的正前方十公尺有一台車」，電腦會以為車在前面，其實在右邊。左前角那顆雷達也一樣，它口中的「正前方」，是車子的左邊。
+              <a:rPr sz="800" lang="zh-TW" dirty="0">
+                <a:solidFill>
+                  <a:srgbClr val="000000"/>
+                </a:solidFill>
+                <a:latin typeface="Arial Unicode MS"/>
+                <a:ea typeface="Arial Unicode MS"/>
+                <a:cs typeface="Arial Unicode MS"/>
+              </a:rPr>
+              <a:t>外參到底是什麼？就是每一顆六個數字。位置三個：往前多少、往左多少、離地多高。方向三個：左右轉了幾度、上下仰了幾度、有沒有歪向一邊。nuScenes 每一顆感測器都附了這六個數字，舉幾個真的：前方相機裝在後輪軸往前一點七公尺、離地一點五公尺；光達在後輪軸往前零點九公尺、離地一點八公尺；前雷達在最前面，往前三點四公尺、離地零點五公尺；左前角那顆雷達，往前二點四公尺、往左零點八公尺，而且它是</a:t>
+            </a:r>
+            <a:r>
+              <a:rPr sz="800" b="1" lang="zh-TW" dirty="0">
+                <a:solidFill>
+                  <a:srgbClr val="000000"/>
+                </a:solidFill>
+                <a:latin typeface="Arial Unicode MS"/>
+                <a:ea typeface="Arial Unicode MS"/>
+                <a:cs typeface="Arial Unicode MS"/>
+              </a:rPr>
+              <a:t>朝左邊</a:t>
+            </a:r>
+            <a:r>
+              <a:rPr sz="800" lang="zh-TW" dirty="0">
+                <a:solidFill>
+                  <a:srgbClr val="000000"/>
+                </a:solidFill>
+                <a:latin typeface="Arial Unicode MS"/>
+                <a:ea typeface="Arial Unicode MS"/>
+                <a:cs typeface="Arial Unicode MS"/>
+              </a:rPr>
+              <a:t>裝的。
 </a:t>
             </a:r>
           </a:p>
@@ -4201,41 +4267,41 @@
                 <a:spcPts val="0"/>
               </a:spcBef>
               <a:spcAft>
-                <a:spcPts val="150"/>
+                <a:spcPts val="133"/>
               </a:spcAft>
             </a:pPr>
             <a:r>
-              <a:rPr sz="900" lang="zh-TW" dirty="0">
-                <a:solidFill>
-                  <a:srgbClr val="000000"/>
-                </a:solidFill>
-                <a:latin typeface="Arial Unicode MS"/>
-                <a:ea typeface="Arial Unicode MS"/>
-                <a:cs typeface="Arial Unicode MS"/>
-              </a:rPr>
-              <a:t>所以外參不是把幾顆感測器調成「看到一樣的畫面」，每一顆看到的本來就不一樣。外參比較像一本</a:t>
-            </a:r>
-            <a:r>
-              <a:rPr sz="900" b="1" lang="zh-TW" dirty="0">
-                <a:solidFill>
-                  <a:srgbClr val="000000"/>
-                </a:solidFill>
-                <a:latin typeface="Arial Unicode MS"/>
-                <a:ea typeface="Arial Unicode MS"/>
-                <a:cs typeface="Arial Unicode MS"/>
-              </a:rPr>
-              <a:t>換算表</a:t>
-            </a:r>
-            <a:r>
-              <a:rPr sz="900" lang="zh-TW" dirty="0">
-                <a:solidFill>
-                  <a:srgbClr val="000000"/>
-                </a:solidFill>
-                <a:latin typeface="Arial Unicode MS"/>
-                <a:ea typeface="Arial Unicode MS"/>
-                <a:cs typeface="Arial Unicode MS"/>
-              </a:rPr>
-              <a:t>：把每一顆用自己的位置講的話，翻成同一種說法，就是「在車子的哪裡」。大家都翻好了，光達的點才能疊到相機的照片上，落在同一台車身上。
+              <a:rPr sz="800" lang="zh-TW" dirty="0">
+                <a:solidFill>
+                  <a:srgbClr val="000000"/>
+                </a:solidFill>
+                <a:latin typeface="Arial Unicode MS"/>
+                <a:ea typeface="Arial Unicode MS"/>
+                <a:cs typeface="Arial Unicode MS"/>
+              </a:rPr>
+              <a:t>方向特別要緊。nuScenes 這顆光達，它自己的「正前方」，其實是朝</a:t>
+            </a:r>
+            <a:r>
+              <a:rPr sz="800" b="1" lang="zh-TW" dirty="0">
+                <a:solidFill>
+                  <a:srgbClr val="000000"/>
+                </a:solidFill>
+                <a:latin typeface="Arial Unicode MS"/>
+                <a:ea typeface="Arial Unicode MS"/>
+                <a:cs typeface="Arial Unicode MS"/>
+              </a:rPr>
+              <a:t>車子的右邊</a:t>
+            </a:r>
+            <a:r>
+              <a:rPr sz="800" lang="zh-TW" dirty="0">
+                <a:solidFill>
+                  <a:srgbClr val="000000"/>
+                </a:solidFill>
+                <a:latin typeface="Arial Unicode MS"/>
+                <a:ea typeface="Arial Unicode MS"/>
+                <a:cs typeface="Arial Unicode MS"/>
+              </a:rPr>
+              <a:t>裝的，轉了九十度。如果不知道這件事，光達說「我的正前方十公尺有一台車」，電腦會以為車在前面，其實在右邊。左前角那顆雷達也一樣，它口中的「正前方」，是車子的左邊。
 </a:t>
             </a:r>
           </a:p>
@@ -4245,19 +4311,41 @@
                 <a:spcPts val="0"/>
               </a:spcBef>
               <a:spcAft>
-                <a:spcPts val="150"/>
+                <a:spcPts val="133"/>
               </a:spcAft>
             </a:pPr>
             <a:r>
-              <a:rPr sz="900" lang="zh-TW" dirty="0">
-                <a:solidFill>
-                  <a:srgbClr val="000000"/>
-                </a:solidFill>
-                <a:latin typeface="Arial Unicode MS"/>
-                <a:ea typeface="Arial Unicode MS"/>
-                <a:cs typeface="Arial Unicode MS"/>
-              </a:rPr>
-              <a:t>看這兩張圖，是同一個瞬間，把光達點投到相機畫面上。顏色是距離：橘色近，藍色遠。
+              <a:rPr sz="800" lang="zh-TW" dirty="0">
+                <a:solidFill>
+                  <a:srgbClr val="000000"/>
+                </a:solidFill>
+                <a:latin typeface="Arial Unicode MS"/>
+                <a:ea typeface="Arial Unicode MS"/>
+                <a:cs typeface="Arial Unicode MS"/>
+              </a:rPr>
+              <a:t>所以外參不是把幾顆感測器調成「看到一樣的畫面」，每一顆看到的本來就不一樣。外參比較像一本</a:t>
+            </a:r>
+            <a:r>
+              <a:rPr sz="800" b="1" lang="zh-TW" dirty="0">
+                <a:solidFill>
+                  <a:srgbClr val="000000"/>
+                </a:solidFill>
+                <a:latin typeface="Arial Unicode MS"/>
+                <a:ea typeface="Arial Unicode MS"/>
+                <a:cs typeface="Arial Unicode MS"/>
+              </a:rPr>
+              <a:t>換算表</a:t>
+            </a:r>
+            <a:r>
+              <a:rPr sz="800" lang="zh-TW" dirty="0">
+                <a:solidFill>
+                  <a:srgbClr val="000000"/>
+                </a:solidFill>
+                <a:latin typeface="Arial Unicode MS"/>
+                <a:ea typeface="Arial Unicode MS"/>
+                <a:cs typeface="Arial Unicode MS"/>
+              </a:rPr>
+              <a:t>：把每一顆用自己的位置講的話，翻成同一種說法，就是「在車子的哪裡」。大家都翻好了，光達的點才能疊到相機的照片上，落在同一台車身上。
 </a:t>
             </a:r>
           </a:p>
@@ -4267,30 +4355,19 @@
                 <a:spcPts val="0"/>
               </a:spcBef>
               <a:spcAft>
-                <a:spcPts val="150"/>
+                <a:spcPts val="133"/>
               </a:spcAft>
             </a:pPr>
             <a:r>
-              <a:rPr sz="900" b="1" lang="zh-TW" dirty="0">
-                <a:solidFill>
-                  <a:srgbClr val="000000"/>
-                </a:solidFill>
-                <a:latin typeface="Arial Unicode MS"/>
-                <a:ea typeface="Arial Unicode MS"/>
-                <a:cs typeface="Arial Unicode MS"/>
-              </a:rPr>
-              <a:t>左邊，標定正確。</a:t>
-            </a:r>
-            <a:r>
-              <a:rPr sz="900" lang="zh-TW" dirty="0">
-                <a:solidFill>
-                  <a:srgbClr val="000000"/>
-                </a:solidFill>
-                <a:latin typeface="Arial Unicode MS"/>
-                <a:ea typeface="Arial Unicode MS"/>
-                <a:cs typeface="Arial Unicode MS"/>
-              </a:rPr>
-              <a:t>前面那台白色廂型車，身上是一排一排整齊的橘色點，大約十公尺；車子右邊的路上、遠處的樹，才是藍色。
+              <a:rPr sz="800" lang="zh-TW" dirty="0">
+                <a:solidFill>
+                  <a:srgbClr val="000000"/>
+                </a:solidFill>
+                <a:latin typeface="Arial Unicode MS"/>
+                <a:ea typeface="Arial Unicode MS"/>
+                <a:cs typeface="Arial Unicode MS"/>
+              </a:rPr>
+              <a:t>看這兩張圖，是同一個瞬間，把光達點投到相機畫面上。顏色是距離：橘色近，藍色遠。
 </a:t>
             </a:r>
           </a:p>
@@ -4300,30 +4377,30 @@
                 <a:spcPts val="0"/>
               </a:spcBef>
               <a:spcAft>
-                <a:spcPts val="150"/>
+                <a:spcPts val="133"/>
               </a:spcAft>
             </a:pPr>
             <a:r>
-              <a:rPr sz="900" b="1" lang="zh-TW" dirty="0">
-                <a:solidFill>
-                  <a:srgbClr val="000000"/>
-                </a:solidFill>
-                <a:latin typeface="Arial Unicode MS"/>
-                <a:ea typeface="Arial Unicode MS"/>
-                <a:cs typeface="Arial Unicode MS"/>
-              </a:rPr>
-              <a:t>右邊，同一格資料，我故意把光達多轉了四度。</a:t>
-            </a:r>
-            <a:r>
-              <a:rPr sz="900" lang="zh-TW" dirty="0">
-                <a:solidFill>
-                  <a:srgbClr val="000000"/>
-                </a:solidFill>
-                <a:latin typeface="Arial Unicode MS"/>
-                <a:ea typeface="Arial Unicode MS"/>
-                <a:cs typeface="Arial Unicode MS"/>
-              </a:rPr>
-              <a:t>請看廂型車的右半邊：後窗上出現了藍色的點，那是遠處的東西；車子左邊的樹和柱子上，反而出現橘色的近處點。光達的點整片滑到左邊去了，它以為車子在左邊一點的位置。
+              <a:rPr sz="800" b="1" lang="zh-TW" dirty="0">
+                <a:solidFill>
+                  <a:srgbClr val="000000"/>
+                </a:solidFill>
+                <a:latin typeface="Arial Unicode MS"/>
+                <a:ea typeface="Arial Unicode MS"/>
+                <a:cs typeface="Arial Unicode MS"/>
+              </a:rPr>
+              <a:t>左邊，標定正確。</a:t>
+            </a:r>
+            <a:r>
+              <a:rPr sz="800" lang="zh-TW" dirty="0">
+                <a:solidFill>
+                  <a:srgbClr val="000000"/>
+                </a:solidFill>
+                <a:latin typeface="Arial Unicode MS"/>
+                <a:ea typeface="Arial Unicode MS"/>
+                <a:cs typeface="Arial Unicode MS"/>
+              </a:rPr>
+              <a:t>前面那台白色廂型車，身上是一排一排整齊的橘色點，大約十公尺；車子右邊的路上、遠處的樹，才是藍色。
 </a:t>
             </a:r>
           </a:p>
@@ -4333,41 +4410,30 @@
                 <a:spcPts val="0"/>
               </a:spcBef>
               <a:spcAft>
-                <a:spcPts val="150"/>
+                <a:spcPts val="133"/>
               </a:spcAft>
             </a:pPr>
             <a:r>
-              <a:rPr sz="900" lang="zh-TW" dirty="0">
-                <a:solidFill>
-                  <a:srgbClr val="000000"/>
-                </a:solidFill>
-                <a:latin typeface="Arial Unicode MS"/>
-                <a:ea typeface="Arial Unicode MS"/>
-                <a:cs typeface="Arial Unicode MS"/>
-              </a:rPr>
-              <a:t>四度是我故意放大的。真的車上，標定可能只差零點幾度，可是第五週算過：</a:t>
-            </a:r>
-            <a:r>
-              <a:rPr sz="900" b="1" lang="zh-TW" dirty="0">
-                <a:solidFill>
-                  <a:srgbClr val="000000"/>
-                </a:solidFill>
-                <a:latin typeface="Arial Unicode MS"/>
-                <a:ea typeface="Arial Unicode MS"/>
-                <a:cs typeface="Arial Unicode MS"/>
-              </a:rPr>
-              <a:t>差一度，五十公尺外就差零點八七公尺</a:t>
-            </a:r>
-            <a:r>
-              <a:rPr sz="900" lang="zh-TW" dirty="0">
-                <a:solidFill>
-                  <a:srgbClr val="000000"/>
-                </a:solidFill>
-                <a:latin typeface="Arial Unicode MS"/>
-                <a:ea typeface="Arial Unicode MS"/>
-                <a:cs typeface="Arial Unicode MS"/>
-              </a:rPr>
-              <a:t>，快半個車道。
+              <a:rPr sz="800" b="1" lang="zh-TW" dirty="0">
+                <a:solidFill>
+                  <a:srgbClr val="000000"/>
+                </a:solidFill>
+                <a:latin typeface="Arial Unicode MS"/>
+                <a:ea typeface="Arial Unicode MS"/>
+                <a:cs typeface="Arial Unicode MS"/>
+              </a:rPr>
+              <a:t>右邊，同一格資料，我故意把光達多轉了四度。</a:t>
+            </a:r>
+            <a:r>
+              <a:rPr sz="800" lang="zh-TW" dirty="0">
+                <a:solidFill>
+                  <a:srgbClr val="000000"/>
+                </a:solidFill>
+                <a:latin typeface="Arial Unicode MS"/>
+                <a:ea typeface="Arial Unicode MS"/>
+                <a:cs typeface="Arial Unicode MS"/>
+              </a:rPr>
+              <a:t>請看廂型車的右半邊：後窗上出現了藍色的點，那是遠處的東西；車子左邊的樹和柱子上，反而出現橘色的近處點。光達的點整片滑到左邊去了，它以為車子在左邊一點的位置。
 </a:t>
             </a:r>
           </a:p>
@@ -4377,129 +4443,41 @@
                 <a:spcPts val="0"/>
               </a:spcBef>
               <a:spcAft>
-                <a:spcPts val="150"/>
+                <a:spcPts val="133"/>
               </a:spcAft>
             </a:pPr>
             <a:r>
-              <a:rPr sz="900" lang="zh-TW" dirty="0">
-                <a:solidFill>
-                  <a:srgbClr val="000000"/>
-                </a:solidFill>
-                <a:latin typeface="Arial Unicode MS"/>
-                <a:ea typeface="Arial Unicode MS"/>
-                <a:cs typeface="Arial Unicode MS"/>
-              </a:rPr>
-              <a:t>nuScenes 是怎麼標定的？它的論文寫了四步。</a:t>
-            </a:r>
-            <a:r>
-              <a:rPr sz="900" b="1" lang="zh-TW" dirty="0">
-                <a:solidFill>
-                  <a:srgbClr val="000000"/>
-                </a:solidFill>
-                <a:latin typeface="Arial Unicode MS"/>
-                <a:ea typeface="Arial Unicode MS"/>
-                <a:cs typeface="Arial Unicode MS"/>
-              </a:rPr>
-              <a:t>光達</a:t>
-            </a:r>
-            <a:r>
-              <a:rPr sz="900" lang="zh-TW" dirty="0">
-                <a:solidFill>
-                  <a:srgbClr val="000000"/>
-                </a:solidFill>
-                <a:latin typeface="Arial Unicode MS"/>
-                <a:ea typeface="Arial Unicode MS"/>
-                <a:cs typeface="Arial Unicode MS"/>
-              </a:rPr>
-              <a:t>：用雷射水平儀，直接量它離車子的原點，也就是後輪軸的正中間，有多遠。</a:t>
-            </a:r>
-            <a:r>
-              <a:rPr sz="900" b="1" lang="zh-TW" dirty="0">
-                <a:solidFill>
-                  <a:srgbClr val="000000"/>
-                </a:solidFill>
-                <a:latin typeface="Arial Unicode MS"/>
-                <a:ea typeface="Arial Unicode MS"/>
-                <a:cs typeface="Arial Unicode MS"/>
-              </a:rPr>
-              <a:t>相機</a:t>
-            </a:r>
-            <a:r>
-              <a:rPr sz="900" lang="zh-TW" dirty="0">
-                <a:solidFill>
-                  <a:srgbClr val="000000"/>
-                </a:solidFill>
-                <a:latin typeface="Arial Unicode MS"/>
-                <a:ea typeface="Arial Unicode MS"/>
-                <a:cs typeface="Arial Unicode MS"/>
-              </a:rPr>
-              <a:t>：在車前擺一個三面都有圖案的立方體校正靶，相機和光達同時看它，算出相機跟光達的相對位置，再接回車身。</a:t>
-            </a:r>
-            <a:r>
-              <a:rPr sz="900" b="1" lang="zh-TW" dirty="0">
-                <a:solidFill>
-                  <a:srgbClr val="000000"/>
-                </a:solidFill>
-                <a:latin typeface="Arial Unicode MS"/>
-                <a:ea typeface="Arial Unicode MS"/>
-                <a:cs typeface="Arial Unicode MS"/>
-              </a:rPr>
-              <a:t>雷達</a:t>
-            </a:r>
-            <a:r>
-              <a:rPr sz="900" lang="zh-TW" dirty="0">
-                <a:solidFill>
-                  <a:srgbClr val="000000"/>
-                </a:solidFill>
-                <a:latin typeface="Arial Unicode MS"/>
-                <a:ea typeface="Arial Unicode MS"/>
-                <a:cs typeface="Arial Unicode MS"/>
-              </a:rPr>
-              <a:t>：先水平裝好，再開車上路，用路邊靜止的東西，反推它左右裝歪了幾度。</a:t>
-            </a:r>
-            <a:r>
-              <a:rPr sz="900" b="1" lang="zh-TW" dirty="0">
-                <a:solidFill>
-                  <a:srgbClr val="000000"/>
-                </a:solidFill>
-                <a:latin typeface="Arial Unicode MS"/>
-                <a:ea typeface="Arial Unicode MS"/>
-                <a:cs typeface="Arial Unicode MS"/>
-              </a:rPr>
-              <a:t>相機的內參</a:t>
-            </a:r>
-            <a:r>
-              <a:rPr sz="900" lang="zh-TW" dirty="0">
-                <a:solidFill>
-                  <a:srgbClr val="000000"/>
-                </a:solidFill>
-                <a:latin typeface="Arial Unicode MS"/>
-                <a:ea typeface="Arial Unicode MS"/>
-                <a:cs typeface="Arial Unicode MS"/>
-              </a:rPr>
-              <a:t>：用一塊印了固定圖案的校正板，算出鏡頭的變形。而且收資料的半年裡，這些數字大約</a:t>
-            </a:r>
-            <a:r>
-              <a:rPr sz="900" b="1" lang="zh-TW" dirty="0">
-                <a:solidFill>
-                  <a:srgbClr val="000000"/>
-                </a:solidFill>
-                <a:latin typeface="Arial Unicode MS"/>
-                <a:ea typeface="Arial Unicode MS"/>
-                <a:cs typeface="Arial Unicode MS"/>
-              </a:rPr>
-              <a:t>每個星期更新兩次</a:t>
-            </a:r>
-            <a:r>
-              <a:rPr sz="900" lang="zh-TW" dirty="0">
-                <a:solidFill>
-                  <a:srgbClr val="000000"/>
-                </a:solidFill>
-                <a:latin typeface="Arial Unicode MS"/>
-                <a:ea typeface="Arial Unicode MS"/>
-                <a:cs typeface="Arial Unicode MS"/>
-              </a:rPr>
-              <a:t>：車子每天在路上震動，標定是會跑掉的。
+              <a:rPr sz="800" lang="zh-TW" dirty="0">
+                <a:solidFill>
+                  <a:srgbClr val="000000"/>
+                </a:solidFill>
+                <a:latin typeface="Arial Unicode MS"/>
+                <a:ea typeface="Arial Unicode MS"/>
+                <a:cs typeface="Arial Unicode MS"/>
+              </a:rPr>
+              <a:t>四度是我故意放大的。真的車上，標定可能只差零點幾度，可是第五週算過：</a:t>
+            </a:r>
+            <a:r>
+              <a:rPr sz="800" b="1" lang="zh-TW" dirty="0">
+                <a:solidFill>
+                  <a:srgbClr val="000000"/>
+                </a:solidFill>
+                <a:latin typeface="Arial Unicode MS"/>
+                <a:ea typeface="Arial Unicode MS"/>
+                <a:cs typeface="Arial Unicode MS"/>
+              </a:rPr>
+              <a:t>差一度，五十公尺外就差零點八七公尺</a:t>
+            </a:r>
+            <a:r>
+              <a:rPr sz="800" lang="zh-TW" dirty="0">
+                <a:solidFill>
+                  <a:srgbClr val="000000"/>
+                </a:solidFill>
+                <a:latin typeface="Arial Unicode MS"/>
+                <a:ea typeface="Arial Unicode MS"/>
+                <a:cs typeface="Arial Unicode MS"/>
+              </a:rPr>
+              <a:t>，快半個車道。
 </a:t>
             </a:r>
           </a:p>
@@ -4509,11 +4487,143 @@
                 <a:spcPts val="0"/>
               </a:spcBef>
               <a:spcAft>
-                <a:spcPts val="150"/>
+                <a:spcPts val="133"/>
               </a:spcAft>
             </a:pPr>
             <a:r>
-              <a:rPr sz="900" lang="zh-TW" dirty="0">
+              <a:rPr sz="800" lang="zh-TW" dirty="0">
+                <a:solidFill>
+                  <a:srgbClr val="000000"/>
+                </a:solidFill>
+                <a:latin typeface="Arial Unicode MS"/>
+                <a:ea typeface="Arial Unicode MS"/>
+                <a:cs typeface="Arial Unicode MS"/>
+              </a:rPr>
+              <a:t>nuScenes 是怎麼標定的？它的論文寫了四步。</a:t>
+            </a:r>
+            <a:r>
+              <a:rPr sz="800" b="1" lang="zh-TW" dirty="0">
+                <a:solidFill>
+                  <a:srgbClr val="000000"/>
+                </a:solidFill>
+                <a:latin typeface="Arial Unicode MS"/>
+                <a:ea typeface="Arial Unicode MS"/>
+                <a:cs typeface="Arial Unicode MS"/>
+              </a:rPr>
+              <a:t>光達</a:t>
+            </a:r>
+            <a:r>
+              <a:rPr sz="800" lang="zh-TW" dirty="0">
+                <a:solidFill>
+                  <a:srgbClr val="000000"/>
+                </a:solidFill>
+                <a:latin typeface="Arial Unicode MS"/>
+                <a:ea typeface="Arial Unicode MS"/>
+                <a:cs typeface="Arial Unicode MS"/>
+              </a:rPr>
+              <a:t>：用雷射水平儀，直接量它離車子的原點，也就是後輪軸的正中間，有多遠。</a:t>
+            </a:r>
+            <a:r>
+              <a:rPr sz="800" b="1" lang="zh-TW" dirty="0">
+                <a:solidFill>
+                  <a:srgbClr val="000000"/>
+                </a:solidFill>
+                <a:latin typeface="Arial Unicode MS"/>
+                <a:ea typeface="Arial Unicode MS"/>
+                <a:cs typeface="Arial Unicode MS"/>
+              </a:rPr>
+              <a:t>相機</a:t>
+            </a:r>
+            <a:r>
+              <a:rPr sz="800" lang="zh-TW" dirty="0">
+                <a:solidFill>
+                  <a:srgbClr val="000000"/>
+                </a:solidFill>
+                <a:latin typeface="Arial Unicode MS"/>
+                <a:ea typeface="Arial Unicode MS"/>
+                <a:cs typeface="Arial Unicode MS"/>
+              </a:rPr>
+              <a:t>：在車前擺一個三面都有圖案的立方體校正靶，相機和光達同時看它，算出相機跟光達的相對位置，再接回車身。</a:t>
+            </a:r>
+            <a:r>
+              <a:rPr sz="800" b="1" lang="zh-TW" dirty="0">
+                <a:solidFill>
+                  <a:srgbClr val="000000"/>
+                </a:solidFill>
+                <a:latin typeface="Arial Unicode MS"/>
+                <a:ea typeface="Arial Unicode MS"/>
+                <a:cs typeface="Arial Unicode MS"/>
+              </a:rPr>
+              <a:t>雷達</a:t>
+            </a:r>
+            <a:r>
+              <a:rPr sz="800" lang="zh-TW" dirty="0">
+                <a:solidFill>
+                  <a:srgbClr val="000000"/>
+                </a:solidFill>
+                <a:latin typeface="Arial Unicode MS"/>
+                <a:ea typeface="Arial Unicode MS"/>
+                <a:cs typeface="Arial Unicode MS"/>
+              </a:rPr>
+              <a:t>：先水平裝好，再開車上路，用路邊靜止的東西，反推它左右裝歪了幾度。</a:t>
+            </a:r>
+            <a:r>
+              <a:rPr sz="800" b="1" lang="zh-TW" dirty="0">
+                <a:solidFill>
+                  <a:srgbClr val="000000"/>
+                </a:solidFill>
+                <a:latin typeface="Arial Unicode MS"/>
+                <a:ea typeface="Arial Unicode MS"/>
+                <a:cs typeface="Arial Unicode MS"/>
+              </a:rPr>
+              <a:t>相機的內參</a:t>
+            </a:r>
+            <a:r>
+              <a:rPr sz="800" lang="zh-TW" dirty="0">
+                <a:solidFill>
+                  <a:srgbClr val="000000"/>
+                </a:solidFill>
+                <a:latin typeface="Arial Unicode MS"/>
+                <a:ea typeface="Arial Unicode MS"/>
+                <a:cs typeface="Arial Unicode MS"/>
+              </a:rPr>
+              <a:t>：用一塊印了固定圖案的校正板，算出鏡頭的變形。而且收資料的半年裡，這些數字大約</a:t>
+            </a:r>
+            <a:r>
+              <a:rPr sz="800" b="1" lang="zh-TW" dirty="0">
+                <a:solidFill>
+                  <a:srgbClr val="000000"/>
+                </a:solidFill>
+                <a:latin typeface="Arial Unicode MS"/>
+                <a:ea typeface="Arial Unicode MS"/>
+                <a:cs typeface="Arial Unicode MS"/>
+              </a:rPr>
+              <a:t>每個星期更新兩次</a:t>
+            </a:r>
+            <a:r>
+              <a:rPr sz="800" lang="zh-TW" dirty="0">
+                <a:solidFill>
+                  <a:srgbClr val="000000"/>
+                </a:solidFill>
+                <a:latin typeface="Arial Unicode MS"/>
+                <a:ea typeface="Arial Unicode MS"/>
+                <a:cs typeface="Arial Unicode MS"/>
+              </a:rPr>
+              <a:t>：車子每天在路上震動，標定是會跑掉的。
+</a:t>
+            </a:r>
+          </a:p>
+          <a:p>
+            <a:pPr algn="l">
+              <a:spcBef>
+                <a:spcPts val="0"/>
+              </a:spcBef>
+              <a:spcAft>
+                <a:spcPts val="133"/>
+              </a:spcAft>
+            </a:pPr>
+            <a:r>
+              <a:rPr sz="800" lang="zh-TW" dirty="0">
                 <a:solidFill>
                   <a:srgbClr val="000000"/>
                 </a:solidFill>
@@ -12250,7 +12360,7 @@
                 <a:ea typeface="Arial" pitchFamily="34" charset="-122"/>
                 <a:cs typeface="Arial" pitchFamily="34" charset="-120"/>
               </a:rPr>
-              <a:t>Điều kiện 1 · 先對齊空間：標定</a:t>
+              <a:t>Điều kiện 1 · 先對齊空間：標定（內參＋外參）</a:t>
             </a:r>
             <a:endParaRPr lang="en-US" sz="1300" dirty="0"/>
           </a:p>

</xml_diff>

<commit_message>
Week 7 L2 slide 7: explain why early/mid/late fusion need different alignment precision
Co-Authored-By: Claude Opus 5.5 <noreply@anthropic.com>
</commit_message>
<xml_diff>
--- a/第七週(10-22)/第七週_第2節_簡報.pptx
+++ b/第七週(10-22)/第七週_第2節_簡報.pptx
@@ -5455,11 +5455,11 @@
                 <a:spcPts val="0"/>
               </a:spcBef>
               <a:spcAft>
-                <a:spcPts val="233"/>
+                <a:spcPts val="167"/>
               </a:spcAft>
             </a:pPr>
             <a:r>
-              <a:rPr sz="1400" b="1" lang="zh-TW" dirty="0">
+              <a:rPr sz="1000" b="1" lang="zh-TW" dirty="0">
                 <a:solidFill>
                   <a:srgbClr val="000000"/>
                 </a:solidFill>
@@ -5470,7 +5470,7 @@
               <a:t>這一張的目的：</a:t>
             </a:r>
             <a:r>
-              <a:rPr sz="1400" lang="zh-TW" dirty="0">
+              <a:rPr sz="1000" lang="zh-TW" dirty="0">
                 <a:solidFill>
                   <a:srgbClr val="000000"/>
                 </a:solidFill>
@@ -5488,11 +5488,11 @@
                 <a:spcPts val="0"/>
               </a:spcBef>
               <a:spcAft>
-                <a:spcPts val="233"/>
+                <a:spcPts val="167"/>
               </a:spcAft>
             </a:pPr>
             <a:r>
-              <a:rPr sz="1400" lang="zh-TW" dirty="0">
+              <a:rPr sz="1000" lang="zh-TW" dirty="0">
                 <a:solidFill>
                   <a:srgbClr val="000000"/>
                 </a:solidFill>
@@ -5510,11 +5510,11 @@
                 <a:spcPts val="0"/>
               </a:spcBef>
               <a:spcAft>
-                <a:spcPts val="233"/>
+                <a:spcPts val="167"/>
               </a:spcAft>
             </a:pPr>
             <a:r>
-              <a:rPr sz="1400" b="1" lang="zh-TW" dirty="0">
+              <a:rPr sz="1000" b="1" lang="zh-TW" dirty="0">
                 <a:solidFill>
                   <a:srgbClr val="000000"/>
                 </a:solidFill>
@@ -5525,7 +5525,7 @@
               <a:t>前期融合</a:t>
             </a:r>
             <a:r>
-              <a:rPr sz="1400" lang="zh-TW" dirty="0">
+              <a:rPr sz="1000" lang="zh-TW" dirty="0">
                 <a:solidFill>
                   <a:srgbClr val="000000"/>
                 </a:solidFill>
@@ -5543,11 +5543,11 @@
                 <a:spcPts val="0"/>
               </a:spcBef>
               <a:spcAft>
-                <a:spcPts val="233"/>
+                <a:spcPts val="167"/>
               </a:spcAft>
             </a:pPr>
             <a:r>
-              <a:rPr sz="1400" b="1" lang="zh-TW" dirty="0">
+              <a:rPr sz="1000" b="1" lang="zh-TW" dirty="0">
                 <a:solidFill>
                   <a:srgbClr val="000000"/>
                 </a:solidFill>
@@ -5558,7 +5558,7 @@
               <a:t>中期融合</a:t>
             </a:r>
             <a:r>
-              <a:rPr sz="1400" lang="zh-TW" dirty="0">
+              <a:rPr sz="1000" lang="zh-TW" dirty="0">
                 <a:solidFill>
                   <a:srgbClr val="000000"/>
                 </a:solidFill>
@@ -5576,11 +5576,11 @@
                 <a:spcPts val="0"/>
               </a:spcBef>
               <a:spcAft>
-                <a:spcPts val="233"/>
+                <a:spcPts val="167"/>
               </a:spcAft>
             </a:pPr>
             <a:r>
-              <a:rPr sz="1400" b="1" lang="zh-TW" dirty="0">
+              <a:rPr sz="1000" b="1" lang="zh-TW" dirty="0">
                 <a:solidFill>
                   <a:srgbClr val="000000"/>
                 </a:solidFill>
@@ -5591,7 +5591,7 @@
               <a:t>後期融合</a:t>
             </a:r>
             <a:r>
-              <a:rPr sz="1400" lang="zh-TW" dirty="0">
+              <a:rPr sz="1000" lang="zh-TW" dirty="0">
                 <a:solidFill>
                   <a:srgbClr val="000000"/>
                 </a:solidFill>
@@ -5609,41 +5609,30 @@
                 <a:spcPts val="0"/>
               </a:spcBef>
               <a:spcAft>
-                <a:spcPts val="233"/>
+                <a:spcPts val="167"/>
               </a:spcAft>
             </a:pPr>
             <a:r>
-              <a:rPr sz="1400" lang="zh-TW" dirty="0">
-                <a:solidFill>
-                  <a:srgbClr val="000000"/>
-                </a:solidFill>
-                <a:latin typeface="Arial Unicode MS"/>
-                <a:ea typeface="Arial Unicode MS"/>
-                <a:cs typeface="Arial Unicode MS"/>
-              </a:rPr>
-              <a:t>再橫著讀兩列：「留下的資訊」和「對齊要多準」，剛好相反。</a:t>
-            </a:r>
-            <a:r>
-              <a:rPr sz="1400" b="1" lang="zh-TW" dirty="0">
-                <a:solidFill>
-                  <a:srgbClr val="000000"/>
-                </a:solidFill>
-                <a:latin typeface="Arial Unicode MS"/>
-                <a:ea typeface="Arial Unicode MS"/>
-                <a:cs typeface="Arial Unicode MS"/>
-              </a:rPr>
-              <a:t>留下的資訊愈多，對齊就要愈準。</a:t>
-            </a:r>
-            <a:r>
-              <a:rPr sz="1400" lang="zh-TW" dirty="0">
-                <a:solidFill>
-                  <a:srgbClr val="000000"/>
-                </a:solidFill>
-                <a:latin typeface="Arial Unicode MS"/>
-                <a:ea typeface="Arial Unicode MS"/>
-                <a:cs typeface="Arial Unicode MS"/>
-              </a:rPr>
-              <a:t>就像一個團隊做報告：前期是把每個人的原始資料丟進同一個資料夾一起看，最完整，可是格式要先統一；後期是每個人先寫好自己的結論再合成一份，最省事，可是每個人沒寫進結論的細節就看不到了。
+              <a:rPr sz="1000" b="1" lang="zh-TW" dirty="0">
+                <a:solidFill>
+                  <a:srgbClr val="000000"/>
+                </a:solidFill>
+                <a:latin typeface="Arial Unicode MS"/>
+                <a:ea typeface="Arial Unicode MS"/>
+                <a:cs typeface="Arial Unicode MS"/>
+              </a:rPr>
+              <a:t>為什麼「對齊要多準」差這麼多？</a:t>
+            </a:r>
+            <a:r>
+              <a:rPr sz="1000" lang="zh-TW" dirty="0">
+                <a:solidFill>
+                  <a:srgbClr val="000000"/>
+                </a:solidFill>
+                <a:latin typeface="Arial Unicode MS"/>
+                <a:ea typeface="Arial Unicode MS"/>
+                <a:cs typeface="Arial Unicode MS"/>
+              </a:rPr>
+              <a:t>看合的時候，要對準的東西有多大。
 </a:t>
             </a:r>
           </a:p>
@@ -5653,11 +5642,176 @@
                 <a:spcPts val="0"/>
               </a:spcBef>
               <a:spcAft>
-                <a:spcPts val="233"/>
+                <a:spcPts val="167"/>
               </a:spcAft>
             </a:pPr>
             <a:r>
-              <a:rPr sz="1400" lang="zh-TW" dirty="0">
+              <a:rPr sz="1000" b="1" lang="zh-TW" dirty="0">
+                <a:solidFill>
+                  <a:srgbClr val="000000"/>
+                </a:solidFill>
+                <a:latin typeface="Arial Unicode MS"/>
+                <a:ea typeface="Arial Unicode MS"/>
+                <a:cs typeface="Arial Unicode MS"/>
+              </a:rPr>
+              <a:t>前期融合，要對準的是一個點。</a:t>
+            </a:r>
+            <a:r>
+              <a:rPr sz="1000" lang="zh-TW" dirty="0">
+                <a:solidFill>
+                  <a:srgbClr val="000000"/>
+                </a:solidFill>
+                <a:latin typeface="Arial Unicode MS"/>
+                <a:ea typeface="Arial Unicode MS"/>
+                <a:cs typeface="Arial Unicode MS"/>
+              </a:rPr>
+              <a:t>光達的每一個點，都要落在照片上對的那個像素。一個行人大約七十公分寬，站在二十公尺外；角度只要差一度，點就偏三十五公分，差不多一半的點會打到他旁邊的背景上，照片上這個人的距離就錯了。第四張故意轉四度，整片點都滑掉。所以要最準。
+</a:t>
+            </a:r>
+          </a:p>
+          <a:p>
+            <a:pPr algn="l">
+              <a:spcBef>
+                <a:spcPts val="0"/>
+              </a:spcBef>
+              <a:spcAft>
+                <a:spcPts val="167"/>
+              </a:spcAft>
+            </a:pPr>
+            <a:r>
+              <a:rPr sz="1000" b="1" lang="zh-TW" dirty="0">
+                <a:solidFill>
+                  <a:srgbClr val="000000"/>
+                </a:solidFill>
+                <a:latin typeface="Arial Unicode MS"/>
+                <a:ea typeface="Arial Unicode MS"/>
+                <a:cs typeface="Arial Unicode MS"/>
+              </a:rPr>
+              <a:t>中期融合，要對準的是一格。</a:t>
+            </a:r>
+            <a:r>
+              <a:rPr sz="1000" lang="zh-TW" dirty="0">
+                <a:solidFill>
+                  <a:srgbClr val="000000"/>
+                </a:solidFill>
+                <a:latin typeface="Arial Unicode MS"/>
+                <a:ea typeface="Arial Unicode MS"/>
+                <a:cs typeface="Arial Unicode MS"/>
+              </a:rPr>
+              <a:t>大家先畫成同一張鳥瞰圖，圖切成一格一格，每一格代表地上的一小塊。偏一點點，東西還在同一格，或是隔壁那一格；而且這種做法是用大量資料訓練出來的，可以學會容忍一點偏差。所以中等。
+</a:t>
+            </a:r>
+          </a:p>
+          <a:p>
+            <a:pPr algn="l">
+              <a:spcBef>
+                <a:spcPts val="0"/>
+              </a:spcBef>
+              <a:spcAft>
+                <a:spcPts val="167"/>
+              </a:spcAft>
+            </a:pPr>
+            <a:r>
+              <a:rPr sz="1000" b="1" lang="zh-TW" dirty="0">
+                <a:solidFill>
+                  <a:srgbClr val="000000"/>
+                </a:solidFill>
+                <a:latin typeface="Arial Unicode MS"/>
+                <a:ea typeface="Arial Unicode MS"/>
+                <a:cs typeface="Arial Unicode MS"/>
+              </a:rPr>
+              <a:t>後期融合，要對準的是一整個物體。</a:t>
+            </a:r>
+            <a:r>
+              <a:rPr sz="1000" lang="zh-TW" dirty="0">
+                <a:solidFill>
+                  <a:srgbClr val="000000"/>
+                </a:solidFill>
+                <a:latin typeface="Arial Unicode MS"/>
+                <a:ea typeface="Arial Unicode MS"/>
+                <a:cs typeface="Arial Unicode MS"/>
+              </a:rPr>
+              <a:t>相機說「前面二十公尺有一台車」，雷達說「前面二十點三公尺有一個目標」，差了三十公分。可是一台車將近兩公尺寬、四公尺半長，三十公分還在車身上，一看就知道是同一台。只要偏差比兩個物體之間的距離小，就對得上。所以最寬鬆。
+</a:t>
+            </a:r>
+          </a:p>
+          <a:p>
+            <a:pPr algn="l">
+              <a:spcBef>
+                <a:spcPts val="0"/>
+              </a:spcBef>
+              <a:spcAft>
+                <a:spcPts val="167"/>
+              </a:spcAft>
+            </a:pPr>
+            <a:r>
+              <a:rPr sz="1000" lang="zh-TW" dirty="0">
+                <a:solidFill>
+                  <a:srgbClr val="000000"/>
+                </a:solidFill>
+                <a:latin typeface="Arial Unicode MS"/>
+                <a:ea typeface="Arial Unicode MS"/>
+                <a:cs typeface="Arial Unicode MS"/>
+              </a:rPr>
+              <a:t>寬鬆不是不用標定。偏差要是大到跟兩台車之間的距離差不多，雷達的目標就會配到隔壁那台車上，「時速三十」被安錯人，這就是第八張講的對應出錯。
+</a:t>
+            </a:r>
+          </a:p>
+          <a:p>
+            <a:pPr algn="l">
+              <a:spcBef>
+                <a:spcPts val="0"/>
+              </a:spcBef>
+              <a:spcAft>
+                <a:spcPts val="167"/>
+              </a:spcAft>
+            </a:pPr>
+            <a:r>
+              <a:rPr sz="1000" lang="zh-TW" dirty="0">
+                <a:solidFill>
+                  <a:srgbClr val="000000"/>
+                </a:solidFill>
+                <a:latin typeface="Arial Unicode MS"/>
+                <a:ea typeface="Arial Unicode MS"/>
+                <a:cs typeface="Arial Unicode MS"/>
+              </a:rPr>
+              <a:t>再橫著讀兩列：「留下的資訊」和「對齊要多準」，剛好相反。</a:t>
+            </a:r>
+            <a:r>
+              <a:rPr sz="1000" b="1" lang="zh-TW" dirty="0">
+                <a:solidFill>
+                  <a:srgbClr val="000000"/>
+                </a:solidFill>
+                <a:latin typeface="Arial Unicode MS"/>
+                <a:ea typeface="Arial Unicode MS"/>
+                <a:cs typeface="Arial Unicode MS"/>
+              </a:rPr>
+              <a:t>留下的資訊愈多，對齊就要愈準。</a:t>
+            </a:r>
+            <a:r>
+              <a:rPr sz="1000" lang="zh-TW" dirty="0">
+                <a:solidFill>
+                  <a:srgbClr val="000000"/>
+                </a:solidFill>
+                <a:latin typeface="Arial Unicode MS"/>
+                <a:ea typeface="Arial Unicode MS"/>
+                <a:cs typeface="Arial Unicode MS"/>
+              </a:rPr>
+              <a:t>就像一個團隊做報告：前期是把每個人的原始資料丟進同一個資料夾一起看，最完整，可是格式要先統一；後期是每個人先寫好自己的結論再合成一份，最省事，可是每個人沒寫進結論的細節就看不到了。
+</a:t>
+            </a:r>
+          </a:p>
+          <a:p>
+            <a:pPr algn="l">
+              <a:spcBef>
+                <a:spcPts val="0"/>
+              </a:spcBef>
+              <a:spcAft>
+                <a:spcPts val="167"/>
+              </a:spcAft>
+            </a:pPr>
+            <a:r>
+              <a:rPr sz="1000" lang="zh-TW" dirty="0">
                 <a:solidFill>
                   <a:srgbClr val="000000"/>
                 </a:solidFill>
@@ -14874,7 +15028,7 @@
       </p:nvGrpSpPr>
       <p:grpSpPr>
         <a:xfrm>
-          <a:off x="472946" y="0"/>
+          <a:off x="589052" y="0"/>
           <a:ext cx="1" cy="1"/>
           <a:chOff x="0" y="0"/>
           <a:chExt cx="0" cy="0"/>
@@ -14888,8 +15042,8 @@
         </p:nvSpPr>
         <p:spPr>
           <a:xfrm>
-            <a:off x="923842" y="262339"/>
-            <a:ext cx="7296316" cy="754226"/>
+            <a:off x="1027176" y="254909"/>
+            <a:ext cx="7089648" cy="732862"/>
           </a:xfrm>
           <a:prstGeom prst="rect">
             <a:avLst/>
@@ -14908,7 +15062,7 @@
               <a:buNone/>
             </a:pPr>
             <a:r>
-              <a:rPr lang="en-US" sz="1970" b="1" dirty="0">
+              <a:rPr lang="en-US" sz="1920" b="1" dirty="0">
                 <a:solidFill>
                   <a:srgbClr val="0B1F3A"/>
                 </a:solidFill>
@@ -14918,7 +15072,7 @@
               </a:rPr>
               <a:t>So sánh ba cách ghép: sớm, giữa, muộn</a:t>
             </a:r>
-            <a:endParaRPr lang="en-US" sz="1970" dirty="0"/>
+            <a:endParaRPr lang="en-US" sz="1920" dirty="0"/>
           </a:p>
           <a:p>
             <a:pPr indent="0" marL="0">
@@ -14928,7 +15082,7 @@
               <a:buNone/>
             </a:pPr>
             <a:r>
-              <a:rPr lang="en-US" sz="1210" dirty="0">
+              <a:rPr lang="en-US" sz="1180" dirty="0">
                 <a:solidFill>
                   <a:srgbClr val="5F7183"/>
                 </a:solidFill>
@@ -14938,7 +15092,7 @@
               </a:rPr>
               <a:t>三種融合比一比：前期、中期、後期</a:t>
             </a:r>
-            <a:endParaRPr lang="en-US" sz="1970" dirty="0"/>
+            <a:endParaRPr lang="en-US" sz="1920" dirty="0"/>
           </a:p>
         </p:txBody>
       </p:sp>
@@ -14957,20 +15111,20 @@
           </p:nvPr>
         </p:nvGraphicFramePr>
         <p:xfrm>
-          <a:off x="923842" y="1016565"/>
-          <a:ext cx="7296316" cy="819811"/>
+          <a:off x="1027176" y="987771"/>
+          <a:ext cx="7089648" cy="796590"/>
         </p:xfrm>
         <a:graphic>
           <a:graphicData uri="http://schemas.openxmlformats.org/drawingml/2006/table">
             <a:tbl>
               <a:tblPr/>
               <a:tblGrid>
-                <a:gridCol w="1434669"/>
-                <a:gridCol w="1967546"/>
-                <a:gridCol w="1967546"/>
-                <a:gridCol w="1926555"/>
+                <a:gridCol w="1394032"/>
+                <a:gridCol w="1911815"/>
+                <a:gridCol w="1911815"/>
+                <a:gridCol w="1871986"/>
               </a:tblGrid>
-              <a:tr h="344321">
+              <a:tr h="334568">
                 <a:tc>
                   <a:txBody>
                     <a:bodyPr/>
@@ -15030,7 +15184,7 @@
                         <a:buNone/>
                       </a:pPr>
                       <a:r>
-                        <a:rPr lang="en-US" sz="900" b="1" dirty="0">
+                        <a:rPr lang="en-US" sz="870" b="1" dirty="0">
                           <a:solidFill>
                             <a:srgbClr val="FFFFFF"/>
                           </a:solidFill>
@@ -15040,14 +15194,14 @@
                         </a:rPr>
                         <a:t>Ghép sớm</a:t>
                       </a:r>
-                      <a:endParaRPr lang="en-US" sz="1080" dirty="0"/>
+                      <a:endParaRPr lang="en-US" sz="1050" dirty="0"/>
                     </a:p>
                     <a:p>
                       <a:pPr algn="l" indent="0" marL="0">
                         <a:buNone/>
                       </a:pPr>
                       <a:r>
-                        <a:rPr lang="en-US" sz="760" dirty="0">
+                        <a:rPr lang="en-US" sz="740" dirty="0">
                           <a:solidFill>
                             <a:srgbClr val="CFE0EC"/>
                           </a:solidFill>
@@ -15057,7 +15211,7 @@
                         </a:rPr>
                         <a:t>前期融合</a:t>
                       </a:r>
-                      <a:endParaRPr lang="en-US" sz="1080" dirty="0"/>
+                      <a:endParaRPr lang="en-US" sz="1050" dirty="0"/>
                     </a:p>
                   </a:txBody>
                   <a:tcPr marL="63500" marR="63500" marT="38100" marB="38100" anchor="ctr">
@@ -15111,7 +15265,7 @@
                         <a:buNone/>
                       </a:pPr>
                       <a:r>
-                        <a:rPr lang="en-US" sz="900" b="1" dirty="0">
+                        <a:rPr lang="en-US" sz="870" b="1" dirty="0">
                           <a:solidFill>
                             <a:srgbClr val="FFFFFF"/>
                           </a:solidFill>
@@ -15121,14 +15275,14 @@
                         </a:rPr>
                         <a:t>Ghép giữa</a:t>
                       </a:r>
-                      <a:endParaRPr lang="en-US" sz="1080" dirty="0"/>
+                      <a:endParaRPr lang="en-US" sz="1050" dirty="0"/>
                     </a:p>
                     <a:p>
                       <a:pPr algn="l" indent="0" marL="0">
                         <a:buNone/>
                       </a:pPr>
                       <a:r>
-                        <a:rPr lang="en-US" sz="760" dirty="0">
+                        <a:rPr lang="en-US" sz="740" dirty="0">
                           <a:solidFill>
                             <a:srgbClr val="CFE0EC"/>
                           </a:solidFill>
@@ -15138,7 +15292,7 @@
                         </a:rPr>
                         <a:t>中期融合</a:t>
                       </a:r>
-                      <a:endParaRPr lang="en-US" sz="1080" dirty="0"/>
+                      <a:endParaRPr lang="en-US" sz="1050" dirty="0"/>
                     </a:p>
                   </a:txBody>
                   <a:tcPr marL="63500" marR="63500" marT="38100" marB="38100" anchor="ctr">
@@ -15192,7 +15346,7 @@
                         <a:buNone/>
                       </a:pPr>
                       <a:r>
-                        <a:rPr lang="en-US" sz="900" b="1" dirty="0">
+                        <a:rPr lang="en-US" sz="870" b="1" dirty="0">
                           <a:solidFill>
                             <a:srgbClr val="FFFFFF"/>
                           </a:solidFill>
@@ -15202,14 +15356,14 @@
                         </a:rPr>
                         <a:t>Ghép muộn</a:t>
                       </a:r>
-                      <a:endParaRPr lang="en-US" sz="1080" dirty="0"/>
+                      <a:endParaRPr lang="en-US" sz="1050" dirty="0"/>
                     </a:p>
                     <a:p>
                       <a:pPr algn="l" indent="0" marL="0">
                         <a:buNone/>
                       </a:pPr>
                       <a:r>
-                        <a:rPr lang="en-US" sz="760" dirty="0">
+                        <a:rPr lang="en-US" sz="740" dirty="0">
                           <a:solidFill>
                             <a:srgbClr val="CFE0EC"/>
                           </a:solidFill>
@@ -15219,7 +15373,7 @@
                         </a:rPr>
                         <a:t>後期融合</a:t>
                       </a:r>
-                      <a:endParaRPr lang="en-US" sz="1080" dirty="0"/>
+                      <a:endParaRPr lang="en-US" sz="1050" dirty="0"/>
                     </a:p>
                   </a:txBody>
                   <a:tcPr marL="63500" marR="63500" marT="38100" marB="38100" anchor="ctr">
@@ -15265,7 +15419,7 @@
                   </a:tcPr>
                 </a:tc>
               </a:tr>
-              <a:tr h="344321">
+              <a:tr h="334568">
                 <a:tc>
                   <a:txBody>
                     <a:bodyPr/>
@@ -15275,7 +15429,7 @@
                         <a:buNone/>
                       </a:pPr>
                       <a:r>
-                        <a:rPr lang="en-US" sz="900" b="1" dirty="0">
+                        <a:rPr lang="en-US" sz="870" b="1" dirty="0">
                           <a:solidFill>
                             <a:srgbClr val="0B1F3A"/>
                           </a:solidFill>
@@ -15285,14 +15439,14 @@
                         </a:rPr>
                         <a:t>Ghép khi nào</a:t>
                       </a:r>
-                      <a:endParaRPr lang="en-US" sz="1080" dirty="0"/>
+                      <a:endParaRPr lang="en-US" sz="1050" dirty="0"/>
                     </a:p>
                     <a:p>
                       <a:pPr algn="l" indent="0" marL="0">
                         <a:buNone/>
                       </a:pPr>
                       <a:r>
-                        <a:rPr lang="en-US" sz="760" dirty="0">
+                        <a:rPr lang="en-US" sz="740" dirty="0">
                           <a:solidFill>
                             <a:srgbClr val="5F7183"/>
                           </a:solidFill>
@@ -15302,7 +15456,7 @@
                         </a:rPr>
                         <a:t>什麼時候合</a:t>
                       </a:r>
-                      <a:endParaRPr lang="en-US" sz="1080" dirty="0"/>
+                      <a:endParaRPr lang="en-US" sz="1050" dirty="0"/>
                     </a:p>
                   </a:txBody>
                   <a:tcPr marL="63500" marR="63500" marT="38100" marB="38100" anchor="ctr">
@@ -15353,7 +15507,7 @@
                         <a:buNone/>
                       </a:pPr>
                       <a:r>
-                        <a:rPr lang="en-US" sz="900" dirty="0">
+                        <a:rPr lang="en-US" sz="870" dirty="0">
                           <a:solidFill>
                             <a:srgbClr val="1A2733"/>
                           </a:solidFill>
@@ -15363,14 +15517,14 @@
                         </a:rPr>
                         <a:t>Ngay dữ liệu gốc</a:t>
                       </a:r>
-                      <a:endParaRPr lang="en-US" sz="1080" dirty="0"/>
+                      <a:endParaRPr lang="en-US" sz="1050" dirty="0"/>
                     </a:p>
                     <a:p>
                       <a:pPr algn="l" indent="0" marL="0">
                         <a:buNone/>
                       </a:pPr>
                       <a:r>
-                        <a:rPr lang="en-US" sz="760" dirty="0">
+                        <a:rPr lang="en-US" sz="740" dirty="0">
                           <a:solidFill>
                             <a:srgbClr val="5F7183"/>
                           </a:solidFill>
@@ -15380,7 +15534,7 @@
                         </a:rPr>
                         <a:t>原始資料就合</a:t>
                       </a:r>
-                      <a:endParaRPr lang="en-US" sz="1080" dirty="0"/>
+                      <a:endParaRPr lang="en-US" sz="1050" dirty="0"/>
                     </a:p>
                   </a:txBody>
                   <a:tcPr marL="63500" marR="63500" marT="38100" marB="38100" anchor="ctr">
@@ -15431,7 +15585,7 @@
                         <a:buNone/>
                       </a:pPr>
                       <a:r>
-                        <a:rPr lang="en-US" sz="900" dirty="0">
+                        <a:rPr lang="en-US" sz="870" dirty="0">
                           <a:solidFill>
                             <a:srgbClr val="1A2733"/>
                           </a:solidFill>
@@ -15441,14 +15595,14 @@
                         </a:rPr>
                         <a:t>Mỗi cái rút đặc trưng rồi ghép</a:t>
                       </a:r>
-                      <a:endParaRPr lang="en-US" sz="1080" dirty="0"/>
+                      <a:endParaRPr lang="en-US" sz="1050" dirty="0"/>
                     </a:p>
                     <a:p>
                       <a:pPr algn="l" indent="0" marL="0">
                         <a:buNone/>
                       </a:pPr>
                       <a:r>
-                        <a:rPr lang="en-US" sz="760" dirty="0">
+                        <a:rPr lang="en-US" sz="740" dirty="0">
                           <a:solidFill>
                             <a:srgbClr val="5F7183"/>
                           </a:solidFill>
@@ -15458,7 +15612,7 @@
                         </a:rPr>
                         <a:t>各自抽出特徵再合</a:t>
                       </a:r>
-                      <a:endParaRPr lang="en-US" sz="1080" dirty="0"/>
+                      <a:endParaRPr lang="en-US" sz="1050" dirty="0"/>
                     </a:p>
                   </a:txBody>
                   <a:tcPr marL="63500" marR="63500" marT="38100" marB="38100" anchor="ctr">
@@ -15509,7 +15663,7 @@
                         <a:buNone/>
                       </a:pPr>
                       <a:r>
-                        <a:rPr lang="en-US" sz="900" dirty="0">
+                        <a:rPr lang="en-US" sz="870" dirty="0">
                           <a:solidFill>
                             <a:srgbClr val="1A2733"/>
                           </a:solidFill>
@@ -15519,14 +15673,14 @@
                         </a:rPr>
                         <a:t>Mỗi cái tự tìm vật rồi ghép</a:t>
                       </a:r>
-                      <a:endParaRPr lang="en-US" sz="1080" dirty="0"/>
+                      <a:endParaRPr lang="en-US" sz="1050" dirty="0"/>
                     </a:p>
                     <a:p>
                       <a:pPr algn="l" indent="0" marL="0">
                         <a:buNone/>
                       </a:pPr>
                       <a:r>
-                        <a:rPr lang="en-US" sz="760" dirty="0">
+                        <a:rPr lang="en-US" sz="740" dirty="0">
                           <a:solidFill>
                             <a:srgbClr val="5F7183"/>
                           </a:solidFill>
@@ -15536,7 +15690,7 @@
                         </a:rPr>
                         <a:t>各自找出物體再合</a:t>
                       </a:r>
-                      <a:endParaRPr lang="en-US" sz="1080" dirty="0"/>
+                      <a:endParaRPr lang="en-US" sz="1050" dirty="0"/>
                     </a:p>
                   </a:txBody>
                   <a:tcPr marL="63500" marR="63500" marT="38100" marB="38100" anchor="ctr">
@@ -15579,7 +15733,7 @@
                   </a:tcPr>
                 </a:tc>
               </a:tr>
-              <a:tr h="344321">
+              <a:tr h="334568">
                 <a:tc>
                   <a:txBody>
                     <a:bodyPr/>
@@ -15589,7 +15743,7 @@
                         <a:buNone/>
                       </a:pPr>
                       <a:r>
-                        <a:rPr lang="en-US" sz="900" b="1" dirty="0">
+                        <a:rPr lang="en-US" sz="870" b="1" dirty="0">
                           <a:solidFill>
                             <a:srgbClr val="0B1F3A"/>
                           </a:solidFill>
@@ -15599,14 +15753,14 @@
                         </a:rPr>
                         <a:t>Ví dụ</a:t>
                       </a:r>
-                      <a:endParaRPr lang="en-US" sz="1080" dirty="0"/>
+                      <a:endParaRPr lang="en-US" sz="1050" dirty="0"/>
                     </a:p>
                     <a:p>
                       <a:pPr algn="l" indent="0" marL="0">
                         <a:buNone/>
                       </a:pPr>
                       <a:r>
-                        <a:rPr lang="en-US" sz="760" dirty="0">
+                        <a:rPr lang="en-US" sz="740" dirty="0">
                           <a:solidFill>
                             <a:srgbClr val="5F7183"/>
                           </a:solidFill>
@@ -15616,7 +15770,7 @@
                         </a:rPr>
                         <a:t>例子</a:t>
                       </a:r>
-                      <a:endParaRPr lang="en-US" sz="1080" dirty="0"/>
+                      <a:endParaRPr lang="en-US" sz="1050" dirty="0"/>
                     </a:p>
                   </a:txBody>
                   <a:tcPr marL="63500" marR="63500" marT="38100" marB="38100" anchor="ctr">
@@ -15667,7 +15821,7 @@
                         <a:buNone/>
                       </a:pPr>
                       <a:r>
-                        <a:rPr lang="en-US" sz="900" dirty="0">
+                        <a:rPr lang="en-US" sz="870" dirty="0">
                           <a:solidFill>
                             <a:srgbClr val="1A2733"/>
                           </a:solidFill>
@@ -15677,14 +15831,14 @@
                         </a:rPr>
                         <a:t>Chiếu điểm lidar lên ảnh (slide 4)</a:t>
                       </a:r>
-                      <a:endParaRPr lang="en-US" sz="1080" dirty="0"/>
+                      <a:endParaRPr lang="en-US" sz="1050" dirty="0"/>
                     </a:p>
                     <a:p>
                       <a:pPr algn="l" indent="0" marL="0">
                         <a:buNone/>
                       </a:pPr>
                       <a:r>
-                        <a:rPr lang="en-US" sz="760" dirty="0">
+                        <a:rPr lang="en-US" sz="740" dirty="0">
                           <a:solidFill>
                             <a:srgbClr val="5F7183"/>
                           </a:solidFill>
@@ -15694,7 +15848,7 @@
                         </a:rPr>
                         <a:t>光達點投到照片（第四張）</a:t>
                       </a:r>
-                      <a:endParaRPr lang="en-US" sz="1080" dirty="0"/>
+                      <a:endParaRPr lang="en-US" sz="1050" dirty="0"/>
                     </a:p>
                   </a:txBody>
                   <a:tcPr marL="63500" marR="63500" marT="38100" marB="38100" anchor="ctr">
@@ -15745,7 +15899,7 @@
                         <a:buNone/>
                       </a:pPr>
                       <a:r>
-                        <a:rPr lang="en-US" sz="900" dirty="0">
+                        <a:rPr lang="en-US" sz="870" dirty="0">
                           <a:solidFill>
                             <a:srgbClr val="1A2733"/>
                           </a:solidFill>
@@ -15755,14 +15909,14 @@
                         </a:rPr>
                         <a:t>Cùng vẽ thành bản đồ nhìn từ trên</a:t>
                       </a:r>
-                      <a:endParaRPr lang="en-US" sz="1080" dirty="0"/>
+                      <a:endParaRPr lang="en-US" sz="1050" dirty="0"/>
                     </a:p>
                     <a:p>
                       <a:pPr algn="l" indent="0" marL="0">
                         <a:buNone/>
                       </a:pPr>
                       <a:r>
-                        <a:rPr lang="en-US" sz="760" dirty="0">
+                        <a:rPr lang="en-US" sz="740" dirty="0">
                           <a:solidFill>
                             <a:srgbClr val="5F7183"/>
                           </a:solidFill>
@@ -15772,7 +15926,7 @@
                         </a:rPr>
                         <a:t>大家先畫成同一張鳥瞰圖</a:t>
                       </a:r>
-                      <a:endParaRPr lang="en-US" sz="1080" dirty="0"/>
+                      <a:endParaRPr lang="en-US" sz="1050" dirty="0"/>
                     </a:p>
                   </a:txBody>
                   <a:tcPr marL="63500" marR="63500" marT="38100" marB="38100" anchor="ctr">
@@ -15823,7 +15977,7 @@
                         <a:buNone/>
                       </a:pPr>
                       <a:r>
-                        <a:rPr lang="en-US" sz="900" dirty="0">
+                        <a:rPr lang="en-US" sz="870" dirty="0">
                           <a:solidFill>
                             <a:srgbClr val="1A2733"/>
                           </a:solidFill>
@@ -15833,14 +15987,14 @@
                         </a:rPr>
                         <a:t>Hộp camera + mục tiêu radar (slide 8)</a:t>
                       </a:r>
-                      <a:endParaRPr lang="en-US" sz="1080" dirty="0"/>
+                      <a:endParaRPr lang="en-US" sz="1050" dirty="0"/>
                     </a:p>
                     <a:p>
                       <a:pPr algn="l" indent="0" marL="0">
                         <a:buNone/>
                       </a:pPr>
                       <a:r>
-                        <a:rPr lang="en-US" sz="760" dirty="0">
+                        <a:rPr lang="en-US" sz="740" dirty="0">
                           <a:solidFill>
                             <a:srgbClr val="5F7183"/>
                           </a:solidFill>
@@ -15850,7 +16004,7 @@
                         </a:rPr>
                         <a:t>相機的框＋雷達的目標（第八張）</a:t>
                       </a:r>
-                      <a:endParaRPr lang="en-US" sz="1080" dirty="0"/>
+                      <a:endParaRPr lang="en-US" sz="1050" dirty="0"/>
                     </a:p>
                   </a:txBody>
                   <a:tcPr marL="63500" marR="63500" marT="38100" marB="38100" anchor="ctr">
@@ -15893,7 +16047,7 @@
                   </a:tcPr>
                 </a:tc>
               </a:tr>
-              <a:tr h="344321">
+              <a:tr h="334568">
                 <a:tc>
                   <a:txBody>
                     <a:bodyPr/>
@@ -15903,7 +16057,7 @@
                         <a:buNone/>
                       </a:pPr>
                       <a:r>
-                        <a:rPr lang="en-US" sz="900" b="1" dirty="0">
+                        <a:rPr lang="en-US" sz="870" b="1" dirty="0">
                           <a:solidFill>
                             <a:srgbClr val="0B1F3A"/>
                           </a:solidFill>
@@ -15913,14 +16067,14 @@
                         </a:rPr>
                         <a:t>Thông tin giữ lại</a:t>
                       </a:r>
-                      <a:endParaRPr lang="en-US" sz="1080" dirty="0"/>
+                      <a:endParaRPr lang="en-US" sz="1050" dirty="0"/>
                     </a:p>
                     <a:p>
                       <a:pPr algn="l" indent="0" marL="0">
                         <a:buNone/>
                       </a:pPr>
                       <a:r>
-                        <a:rPr lang="en-US" sz="760" dirty="0">
+                        <a:rPr lang="en-US" sz="740" dirty="0">
                           <a:solidFill>
                             <a:srgbClr val="5F7183"/>
                           </a:solidFill>
@@ -15930,7 +16084,7 @@
                         </a:rPr>
                         <a:t>留下的資訊</a:t>
                       </a:r>
-                      <a:endParaRPr lang="en-US" sz="1080" dirty="0"/>
+                      <a:endParaRPr lang="en-US" sz="1050" dirty="0"/>
                     </a:p>
                   </a:txBody>
                   <a:tcPr marL="63500" marR="63500" marT="38100" marB="38100" anchor="ctr">
@@ -15981,7 +16135,7 @@
                         <a:buNone/>
                       </a:pPr>
                       <a:r>
-                        <a:rPr lang="en-US" sz="900" dirty="0">
+                        <a:rPr lang="en-US" sz="870" dirty="0">
                           <a:solidFill>
                             <a:srgbClr val="1A2733"/>
                           </a:solidFill>
@@ -15991,14 +16145,14 @@
                         </a:rPr>
                         <a:t>Nhiều nhất</a:t>
                       </a:r>
-                      <a:endParaRPr lang="en-US" sz="1080" dirty="0"/>
+                      <a:endParaRPr lang="en-US" sz="1050" dirty="0"/>
                     </a:p>
                     <a:p>
                       <a:pPr algn="l" indent="0" marL="0">
                         <a:buNone/>
                       </a:pPr>
                       <a:r>
-                        <a:rPr lang="en-US" sz="760" dirty="0">
+                        <a:rPr lang="en-US" sz="740" dirty="0">
                           <a:solidFill>
                             <a:srgbClr val="5F7183"/>
                           </a:solidFill>
@@ -16008,7 +16162,7 @@
                         </a:rPr>
                         <a:t>最多</a:t>
                       </a:r>
-                      <a:endParaRPr lang="en-US" sz="1080" dirty="0"/>
+                      <a:endParaRPr lang="en-US" sz="1050" dirty="0"/>
                     </a:p>
                   </a:txBody>
                   <a:tcPr marL="63500" marR="63500" marT="38100" marB="38100" anchor="ctr">
@@ -16059,7 +16213,7 @@
                         <a:buNone/>
                       </a:pPr>
                       <a:r>
-                        <a:rPr lang="en-US" sz="900" dirty="0">
+                        <a:rPr lang="en-US" sz="870" dirty="0">
                           <a:solidFill>
                             <a:srgbClr val="1A2733"/>
                           </a:solidFill>
@@ -16069,14 +16223,14 @@
                         </a:rPr>
                         <a:t>Vừa</a:t>
                       </a:r>
-                      <a:endParaRPr lang="en-US" sz="1080" dirty="0"/>
+                      <a:endParaRPr lang="en-US" sz="1050" dirty="0"/>
                     </a:p>
                     <a:p>
                       <a:pPr algn="l" indent="0" marL="0">
                         <a:buNone/>
                       </a:pPr>
                       <a:r>
-                        <a:rPr lang="en-US" sz="760" dirty="0">
+                        <a:rPr lang="en-US" sz="740" dirty="0">
                           <a:solidFill>
                             <a:srgbClr val="5F7183"/>
                           </a:solidFill>
@@ -16086,7 +16240,7 @@
                         </a:rPr>
                         <a:t>中等</a:t>
                       </a:r>
-                      <a:endParaRPr lang="en-US" sz="1080" dirty="0"/>
+                      <a:endParaRPr lang="en-US" sz="1050" dirty="0"/>
                     </a:p>
                   </a:txBody>
                   <a:tcPr marL="63500" marR="63500" marT="38100" marB="38100" anchor="ctr">
@@ -16137,7 +16291,7 @@
                         <a:buNone/>
                       </a:pPr>
                       <a:r>
-                        <a:rPr lang="en-US" sz="900" dirty="0">
+                        <a:rPr lang="en-US" sz="870" dirty="0">
                           <a:solidFill>
                             <a:srgbClr val="1A2733"/>
                           </a:solidFill>
@@ -16147,14 +16301,14 @@
                         </a:rPr>
                         <a:t>Ít nhất: cái đã bỏ không lấy lại được</a:t>
                       </a:r>
-                      <a:endParaRPr lang="en-US" sz="1080" dirty="0"/>
+                      <a:endParaRPr lang="en-US" sz="1050" dirty="0"/>
                     </a:p>
                     <a:p>
                       <a:pPr algn="l" indent="0" marL="0">
                         <a:buNone/>
                       </a:pPr>
                       <a:r>
-                        <a:rPr lang="en-US" sz="760" dirty="0">
+                        <a:rPr lang="en-US" sz="740" dirty="0">
                           <a:solidFill>
                             <a:srgbClr val="5F7183"/>
                           </a:solidFill>
@@ -16164,7 +16318,7 @@
                         </a:rPr>
                         <a:t>最少：各自丟掉的拿不回來</a:t>
                       </a:r>
-                      <a:endParaRPr lang="en-US" sz="1080" dirty="0"/>
+                      <a:endParaRPr lang="en-US" sz="1050" dirty="0"/>
                     </a:p>
                   </a:txBody>
                   <a:tcPr marL="63500" marR="63500" marT="38100" marB="38100" anchor="ctr">
@@ -16207,7 +16361,7 @@
                   </a:tcPr>
                 </a:tc>
               </a:tr>
-              <a:tr h="344321">
+              <a:tr h="334568">
                 <a:tc>
                   <a:txBody>
                     <a:bodyPr/>
@@ -16217,7 +16371,7 @@
                         <a:buNone/>
                       </a:pPr>
                       <a:r>
-                        <a:rPr lang="en-US" sz="900" b="1" dirty="0">
+                        <a:rPr lang="en-US" sz="870" b="1" dirty="0">
                           <a:solidFill>
                             <a:srgbClr val="0B1F3A"/>
                           </a:solidFill>
@@ -16227,14 +16381,14 @@
                         </a:rPr>
                         <a:t>Căn chỉnh phải chuẩn</a:t>
                       </a:r>
-                      <a:endParaRPr lang="en-US" sz="1080" dirty="0"/>
+                      <a:endParaRPr lang="en-US" sz="1050" dirty="0"/>
                     </a:p>
                     <a:p>
                       <a:pPr algn="l" indent="0" marL="0">
                         <a:buNone/>
                       </a:pPr>
                       <a:r>
-                        <a:rPr lang="en-US" sz="760" dirty="0">
+                        <a:rPr lang="en-US" sz="740" dirty="0">
                           <a:solidFill>
                             <a:srgbClr val="5F7183"/>
                           </a:solidFill>
@@ -16244,7 +16398,7 @@
                         </a:rPr>
                         <a:t>對齊要多準</a:t>
                       </a:r>
-                      <a:endParaRPr lang="en-US" sz="1080" dirty="0"/>
+                      <a:endParaRPr lang="en-US" sz="1050" dirty="0"/>
                     </a:p>
                   </a:txBody>
                   <a:tcPr marL="63500" marR="63500" marT="38100" marB="38100" anchor="ctr">
@@ -16295,7 +16449,7 @@
                         <a:buNone/>
                       </a:pPr>
                       <a:r>
-                        <a:rPr lang="en-US" sz="900" dirty="0">
+                        <a:rPr lang="en-US" sz="870" dirty="0">
                           <a:solidFill>
                             <a:srgbClr val="1A2733"/>
                           </a:solidFill>
@@ -16303,16 +16457,16 @@
                           <a:ea typeface="Arial" pitchFamily="34" charset="-122"/>
                           <a:cs typeface="Arial" pitchFamily="34" charset="-120"/>
                         </a:rPr>
-                        <a:t>Rất chuẩn (lệch 4° là trượt)</a:t>
+                        <a:t>Rất chuẩn: từng điểm đúng điểm ảnh</a:t>
                       </a:r>
-                      <a:endParaRPr lang="en-US" sz="1080" dirty="0"/>
+                      <a:endParaRPr lang="en-US" sz="1050" dirty="0"/>
                     </a:p>
                     <a:p>
                       <a:pPr algn="l" indent="0" marL="0">
                         <a:buNone/>
                       </a:pPr>
                       <a:r>
-                        <a:rPr lang="en-US" sz="760" dirty="0">
+                        <a:rPr lang="en-US" sz="740" dirty="0">
                           <a:solidFill>
                             <a:srgbClr val="5F7183"/>
                           </a:solidFill>
@@ -16320,9 +16474,9 @@
                           <a:ea typeface="微軟正黑體" pitchFamily="34" charset="-122"/>
                           <a:cs typeface="微軟正黑體" pitchFamily="34" charset="-120"/>
                         </a:rPr>
-                        <a:t>最準（差 4 度就滑掉）</a:t>
+                        <a:t>最準：每個點對到對的像素</a:t>
                       </a:r>
-                      <a:endParaRPr lang="en-US" sz="1080" dirty="0"/>
+                      <a:endParaRPr lang="en-US" sz="1050" dirty="0"/>
                     </a:p>
                   </a:txBody>
                   <a:tcPr marL="63500" marR="63500" marT="38100" marB="38100" anchor="ctr">
@@ -16373,7 +16527,7 @@
                         <a:buNone/>
                       </a:pPr>
                       <a:r>
-                        <a:rPr lang="en-US" sz="900" dirty="0">
+                        <a:rPr lang="en-US" sz="870" dirty="0">
                           <a:solidFill>
                             <a:srgbClr val="1A2733"/>
                           </a:solidFill>
@@ -16381,16 +16535,16 @@
                           <a:ea typeface="Arial" pitchFamily="34" charset="-122"/>
                           <a:cs typeface="Arial" pitchFamily="34" charset="-120"/>
                         </a:rPr>
-                        <a:t>Vừa</a:t>
+                        <a:t>Vừa: đúng cùng một ô</a:t>
                       </a:r>
-                      <a:endParaRPr lang="en-US" sz="1080" dirty="0"/>
+                      <a:endParaRPr lang="en-US" sz="1050" dirty="0"/>
                     </a:p>
                     <a:p>
                       <a:pPr algn="l" indent="0" marL="0">
                         <a:buNone/>
                       </a:pPr>
                       <a:r>
-                        <a:rPr lang="en-US" sz="760" dirty="0">
+                        <a:rPr lang="en-US" sz="740" dirty="0">
                           <a:solidFill>
                             <a:srgbClr val="5F7183"/>
                           </a:solidFill>
@@ -16398,9 +16552,9 @@
                           <a:ea typeface="微軟正黑體" pitchFamily="34" charset="-122"/>
                           <a:cs typeface="微軟正黑體" pitchFamily="34" charset="-120"/>
                         </a:rPr>
-                        <a:t>中等</a:t>
+                        <a:t>中等：對到同一格就好</a:t>
                       </a:r>
-                      <a:endParaRPr lang="en-US" sz="1080" dirty="0"/>
+                      <a:endParaRPr lang="en-US" sz="1050" dirty="0"/>
                     </a:p>
                   </a:txBody>
                   <a:tcPr marL="63500" marR="63500" marT="38100" marB="38100" anchor="ctr">
@@ -16451,7 +16605,7 @@
                         <a:buNone/>
                       </a:pPr>
                       <a:r>
-                        <a:rPr lang="en-US" sz="900" dirty="0">
+                        <a:rPr lang="en-US" sz="870" dirty="0">
                           <a:solidFill>
                             <a:srgbClr val="1A2733"/>
                           </a:solidFill>
@@ -16461,14 +16615,14 @@
                         </a:rPr>
                         <a:t>Dễ hơn: ghép đúng vật là được</a:t>
                       </a:r>
-                      <a:endParaRPr lang="en-US" sz="1080" dirty="0"/>
+                      <a:endParaRPr lang="en-US" sz="1050" dirty="0"/>
                     </a:p>
                     <a:p>
                       <a:pPr algn="l" indent="0" marL="0">
                         <a:buNone/>
                       </a:pPr>
                       <a:r>
-                        <a:rPr lang="en-US" sz="760" dirty="0">
+                        <a:rPr lang="en-US" sz="740" dirty="0">
                           <a:solidFill>
                             <a:srgbClr val="5F7183"/>
                           </a:solidFill>
@@ -16478,7 +16632,7 @@
                         </a:rPr>
                         <a:t>較寬鬆：對到同一個物體就好</a:t>
                       </a:r>
-                      <a:endParaRPr lang="en-US" sz="1080" dirty="0"/>
+                      <a:endParaRPr lang="en-US" sz="1050" dirty="0"/>
                     </a:p>
                   </a:txBody>
                   <a:tcPr marL="63500" marR="63500" marT="38100" marB="38100" anchor="ctr">
@@ -16521,7 +16675,7 @@
                   </a:tcPr>
                 </a:tc>
               </a:tr>
-              <a:tr h="344321">
+              <a:tr h="334568">
                 <a:tc>
                   <a:txBody>
                     <a:bodyPr/>
@@ -16531,7 +16685,7 @@
                         <a:buNone/>
                       </a:pPr>
                       <a:r>
-                        <a:rPr lang="en-US" sz="900" b="1" dirty="0">
+                        <a:rPr lang="en-US" sz="870" b="1" dirty="0">
                           <a:solidFill>
                             <a:srgbClr val="0B1F3A"/>
                           </a:solidFill>
@@ -16541,14 +16695,14 @@
                         </a:rPr>
                         <a:t>Hỏng một cái</a:t>
                       </a:r>
-                      <a:endParaRPr lang="en-US" sz="1080" dirty="0"/>
+                      <a:endParaRPr lang="en-US" sz="1050" dirty="0"/>
                     </a:p>
                     <a:p>
                       <a:pPr algn="l" indent="0" marL="0">
                         <a:buNone/>
                       </a:pPr>
                       <a:r>
-                        <a:rPr lang="en-US" sz="760" dirty="0">
+                        <a:rPr lang="en-US" sz="740" dirty="0">
                           <a:solidFill>
                             <a:srgbClr val="5F7183"/>
                           </a:solidFill>
@@ -16558,7 +16712,7 @@
                         </a:rPr>
                         <a:t>壞一顆的時候</a:t>
                       </a:r>
-                      <a:endParaRPr lang="en-US" sz="1080" dirty="0"/>
+                      <a:endParaRPr lang="en-US" sz="1050" dirty="0"/>
                     </a:p>
                   </a:txBody>
                   <a:tcPr marL="63500" marR="63500" marT="38100" marB="38100" anchor="ctr">
@@ -16609,7 +16763,7 @@
                         <a:buNone/>
                       </a:pPr>
                       <a:r>
-                        <a:rPr lang="en-US" sz="900" dirty="0">
+                        <a:rPr lang="en-US" sz="870" dirty="0">
                           <a:solidFill>
                             <a:srgbClr val="1A2733"/>
                           </a:solidFill>
@@ -16619,14 +16773,14 @@
                         </a:rPr>
                         <a:t>Ảnh hưởng nhiều nhất</a:t>
                       </a:r>
-                      <a:endParaRPr lang="en-US" sz="1080" dirty="0"/>
+                      <a:endParaRPr lang="en-US" sz="1050" dirty="0"/>
                     </a:p>
                     <a:p>
                       <a:pPr algn="l" indent="0" marL="0">
                         <a:buNone/>
                       </a:pPr>
                       <a:r>
-                        <a:rPr lang="en-US" sz="760" dirty="0">
+                        <a:rPr lang="en-US" sz="740" dirty="0">
                           <a:solidFill>
                             <a:srgbClr val="5F7183"/>
                           </a:solidFill>
@@ -16636,7 +16790,7 @@
                         </a:rPr>
                         <a:t>影響最大</a:t>
                       </a:r>
-                      <a:endParaRPr lang="en-US" sz="1080" dirty="0"/>
+                      <a:endParaRPr lang="en-US" sz="1050" dirty="0"/>
                     </a:p>
                   </a:txBody>
                   <a:tcPr marL="63500" marR="63500" marT="38100" marB="38100" anchor="ctr">
@@ -16687,7 +16841,7 @@
                         <a:buNone/>
                       </a:pPr>
                       <a:r>
-                        <a:rPr lang="en-US" sz="900" dirty="0">
+                        <a:rPr lang="en-US" sz="870" dirty="0">
                           <a:solidFill>
                             <a:srgbClr val="1A2733"/>
                           </a:solidFill>
@@ -16697,14 +16851,14 @@
                         </a:rPr>
                         <a:t>Vừa</a:t>
                       </a:r>
-                      <a:endParaRPr lang="en-US" sz="1080" dirty="0"/>
+                      <a:endParaRPr lang="en-US" sz="1050" dirty="0"/>
                     </a:p>
                     <a:p>
                       <a:pPr algn="l" indent="0" marL="0">
                         <a:buNone/>
                       </a:pPr>
                       <a:r>
-                        <a:rPr lang="en-US" sz="760" dirty="0">
+                        <a:rPr lang="en-US" sz="740" dirty="0">
                           <a:solidFill>
                             <a:srgbClr val="5F7183"/>
                           </a:solidFill>
@@ -16714,7 +16868,7 @@
                         </a:rPr>
                         <a:t>中等</a:t>
                       </a:r>
-                      <a:endParaRPr lang="en-US" sz="1080" dirty="0"/>
+                      <a:endParaRPr lang="en-US" sz="1050" dirty="0"/>
                     </a:p>
                   </a:txBody>
                   <a:tcPr marL="63500" marR="63500" marT="38100" marB="38100" anchor="ctr">
@@ -16765,7 +16919,7 @@
                         <a:buNone/>
                       </a:pPr>
                       <a:r>
-                        <a:rPr lang="en-US" sz="900" dirty="0">
+                        <a:rPr lang="en-US" sz="870" dirty="0">
                           <a:solidFill>
                             <a:srgbClr val="1A2733"/>
                           </a:solidFill>
@@ -16775,14 +16929,14 @@
                         </a:rPr>
                         <a:t>Dễ thay, danh sách kia vẫn còn</a:t>
                       </a:r>
-                      <a:endParaRPr lang="en-US" sz="1080" dirty="0"/>
+                      <a:endParaRPr lang="en-US" sz="1050" dirty="0"/>
                     </a:p>
                     <a:p>
                       <a:pPr algn="l" indent="0" marL="0">
                         <a:buNone/>
                       </a:pPr>
                       <a:r>
-                        <a:rPr lang="en-US" sz="760" dirty="0">
+                        <a:rPr lang="en-US" sz="740" dirty="0">
                           <a:solidFill>
                             <a:srgbClr val="5F7183"/>
                           </a:solidFill>
@@ -16792,7 +16946,7 @@
                         </a:rPr>
                         <a:t>最好處理，另一份清單還在</a:t>
                       </a:r>
-                      <a:endParaRPr lang="en-US" sz="1080" dirty="0"/>
+                      <a:endParaRPr lang="en-US" sz="1050" dirty="0"/>
                     </a:p>
                   </a:txBody>
                   <a:tcPr marL="63500" marR="63500" marT="38100" marB="38100" anchor="ctr">
@@ -16835,7 +16989,7 @@
                   </a:tcPr>
                 </a:tc>
               </a:tr>
-              <a:tr h="344321">
+              <a:tr h="334568">
                 <a:tc>
                   <a:txBody>
                     <a:bodyPr/>
@@ -16845,7 +16999,7 @@
                         <a:buNone/>
                       </a:pPr>
                       <a:r>
-                        <a:rPr lang="en-US" sz="900" b="1" dirty="0">
+                        <a:rPr lang="en-US" sz="870" b="1" dirty="0">
                           <a:solidFill>
                             <a:srgbClr val="0B1F3A"/>
                           </a:solidFill>
@@ -16855,14 +17009,14 @@
                         </a:rPr>
                         <a:t>Lượng dữ liệu phải tính</a:t>
                       </a:r>
-                      <a:endParaRPr lang="en-US" sz="1080" dirty="0"/>
+                      <a:endParaRPr lang="en-US" sz="1050" dirty="0"/>
                     </a:p>
                     <a:p>
                       <a:pPr algn="l" indent="0" marL="0">
                         <a:buNone/>
                       </a:pPr>
                       <a:r>
-                        <a:rPr lang="en-US" sz="760" dirty="0">
+                        <a:rPr lang="en-US" sz="740" dirty="0">
                           <a:solidFill>
                             <a:srgbClr val="5F7183"/>
                           </a:solidFill>
@@ -16872,7 +17026,7 @@
                         </a:rPr>
                         <a:t>要處理的資料量</a:t>
                       </a:r>
-                      <a:endParaRPr lang="en-US" sz="1080" dirty="0"/>
+                      <a:endParaRPr lang="en-US" sz="1050" dirty="0"/>
                     </a:p>
                   </a:txBody>
                   <a:tcPr marL="63500" marR="63500" marT="38100" marB="38100" anchor="ctr">
@@ -16923,7 +17077,7 @@
                         <a:buNone/>
                       </a:pPr>
                       <a:r>
-                        <a:rPr lang="en-US" sz="900" dirty="0">
+                        <a:rPr lang="en-US" sz="870" dirty="0">
                           <a:solidFill>
                             <a:srgbClr val="1A2733"/>
                           </a:solidFill>
@@ -16933,14 +17087,14 @@
                         </a:rPr>
                         <a:t>Lớn nhất</a:t>
                       </a:r>
-                      <a:endParaRPr lang="en-US" sz="1080" dirty="0"/>
+                      <a:endParaRPr lang="en-US" sz="1050" dirty="0"/>
                     </a:p>
                     <a:p>
                       <a:pPr algn="l" indent="0" marL="0">
                         <a:buNone/>
                       </a:pPr>
                       <a:r>
-                        <a:rPr lang="en-US" sz="760" dirty="0">
+                        <a:rPr lang="en-US" sz="740" dirty="0">
                           <a:solidFill>
                             <a:srgbClr val="5F7183"/>
                           </a:solidFill>
@@ -16950,7 +17104,7 @@
                         </a:rPr>
                         <a:t>最大</a:t>
                       </a:r>
-                      <a:endParaRPr lang="en-US" sz="1080" dirty="0"/>
+                      <a:endParaRPr lang="en-US" sz="1050" dirty="0"/>
                     </a:p>
                   </a:txBody>
                   <a:tcPr marL="63500" marR="63500" marT="38100" marB="38100" anchor="ctr">
@@ -17001,7 +17155,7 @@
                         <a:buNone/>
                       </a:pPr>
                       <a:r>
-                        <a:rPr lang="en-US" sz="900" dirty="0">
+                        <a:rPr lang="en-US" sz="870" dirty="0">
                           <a:solidFill>
                             <a:srgbClr val="1A2733"/>
                           </a:solidFill>
@@ -17011,14 +17165,14 @@
                         </a:rPr>
                         <a:t>Vừa</a:t>
                       </a:r>
-                      <a:endParaRPr lang="en-US" sz="1080" dirty="0"/>
+                      <a:endParaRPr lang="en-US" sz="1050" dirty="0"/>
                     </a:p>
                     <a:p>
                       <a:pPr algn="l" indent="0" marL="0">
                         <a:buNone/>
                       </a:pPr>
                       <a:r>
-                        <a:rPr lang="en-US" sz="760" dirty="0">
+                        <a:rPr lang="en-US" sz="740" dirty="0">
                           <a:solidFill>
                             <a:srgbClr val="5F7183"/>
                           </a:solidFill>
@@ -17028,7 +17182,7 @@
                         </a:rPr>
                         <a:t>中等</a:t>
                       </a:r>
-                      <a:endParaRPr lang="en-US" sz="1080" dirty="0"/>
+                      <a:endParaRPr lang="en-US" sz="1050" dirty="0"/>
                     </a:p>
                   </a:txBody>
                   <a:tcPr marL="63500" marR="63500" marT="38100" marB="38100" anchor="ctr">
@@ -17079,7 +17233,7 @@
                         <a:buNone/>
                       </a:pPr>
                       <a:r>
-                        <a:rPr lang="en-US" sz="900" dirty="0">
+                        <a:rPr lang="en-US" sz="870" dirty="0">
                           <a:solidFill>
                             <a:srgbClr val="1A2733"/>
                           </a:solidFill>
@@ -17089,14 +17243,14 @@
                         </a:rPr>
                         <a:t>Nhỏ nhất</a:t>
                       </a:r>
-                      <a:endParaRPr lang="en-US" sz="1080" dirty="0"/>
+                      <a:endParaRPr lang="en-US" sz="1050" dirty="0"/>
                     </a:p>
                     <a:p>
                       <a:pPr algn="l" indent="0" marL="0">
                         <a:buNone/>
                       </a:pPr>
                       <a:r>
-                        <a:rPr lang="en-US" sz="760" dirty="0">
+                        <a:rPr lang="en-US" sz="740" dirty="0">
                           <a:solidFill>
                             <a:srgbClr val="5F7183"/>
                           </a:solidFill>
@@ -17106,7 +17260,7 @@
                         </a:rPr>
                         <a:t>最小</a:t>
                       </a:r>
-                      <a:endParaRPr lang="en-US" sz="1080" dirty="0"/>
+                      <a:endParaRPr lang="en-US" sz="1050" dirty="0"/>
                     </a:p>
                   </a:txBody>
                   <a:tcPr marL="63500" marR="63500" marT="38100" marB="38100" anchor="ctr">
@@ -17161,8 +17315,8 @@
         </p:nvSpPr>
         <p:spPr>
           <a:xfrm>
-            <a:off x="923842" y="4219245"/>
-            <a:ext cx="7296316" cy="409905"/>
+            <a:off x="1027176" y="4230855"/>
+            <a:ext cx="7089648" cy="398295"/>
           </a:xfrm>
           <a:prstGeom prst="rect">
             <a:avLst/>
@@ -17181,7 +17335,7 @@
               <a:buNone/>
             </a:pPr>
             <a:r>
-              <a:rPr lang="en-US" sz="1080" b="1" dirty="0">
+              <a:rPr lang="en-US" sz="1050" b="1" dirty="0">
                 <a:solidFill>
                   <a:srgbClr val="007F72"/>
                 </a:solidFill>
@@ -17191,7 +17345,7 @@
               </a:rPr>
               <a:t>Giữ càng nhiều thông tin thì càng phải căn chỉnh chuẩn: không có cách nào thắng ở mọi hàng.</a:t>
             </a:r>
-            <a:endParaRPr lang="en-US" sz="1080" dirty="0"/>
+            <a:endParaRPr lang="en-US" sz="1050" dirty="0"/>
           </a:p>
           <a:p>
             <a:pPr indent="0" marL="0">
@@ -17201,7 +17355,7 @@
               <a:buNone/>
             </a:pPr>
             <a:r>
-              <a:rPr lang="en-US" sz="990" dirty="0">
+              <a:rPr lang="en-US" sz="960" dirty="0">
                 <a:solidFill>
                   <a:srgbClr val="007F72"/>
                 </a:solidFill>
@@ -17211,7 +17365,7 @@
               </a:rPr>
               <a:t>留下的資訊愈多，對齊就要愈準：沒有一種在每一列都贏。</a:t>
             </a:r>
-            <a:endParaRPr lang="en-US" sz="1080" dirty="0"/>
+            <a:endParaRPr lang="en-US" sz="1050" dirty="0"/>
           </a:p>
         </p:txBody>
       </p:sp>
@@ -17247,8 +17401,8 @@
         </p:nvSpPr>
         <p:spPr>
           <a:xfrm>
-            <a:off x="571323" y="114774"/>
-            <a:ext cx="737830" cy="229547"/>
+            <a:off x="684643" y="111523"/>
+            <a:ext cx="716931" cy="223045"/>
           </a:xfrm>
           <a:prstGeom prst="rect">
             <a:avLst/>
@@ -17264,7 +17418,7 @@
               <a:buNone/>
             </a:pPr>
             <a:r>
-              <a:rPr lang="en-US" sz="810" dirty="0">
+              <a:rPr lang="en-US" sz="780" dirty="0">
                 <a:solidFill>
                   <a:srgbClr val="5F7183"/>
                 </a:solidFill>
@@ -17274,7 +17428,7 @@
               </a:rPr>
               <a:t>7 / 13</a:t>
             </a:r>
-            <a:endParaRPr lang="en-US" sz="810" dirty="0"/>
+            <a:endParaRPr lang="en-US" sz="780" dirty="0"/>
           </a:p>
         </p:txBody>
       </p:sp>
@@ -17286,8 +17440,8 @@
         </p:nvSpPr>
         <p:spPr>
           <a:xfrm>
-            <a:off x="1333747" y="114774"/>
-            <a:ext cx="1803584" cy="229547"/>
+            <a:off x="1425471" y="111523"/>
+            <a:ext cx="1752497" cy="223045"/>
           </a:xfrm>
           <a:prstGeom prst="rect">
             <a:avLst/>
@@ -17303,7 +17457,7 @@
               <a:buNone/>
             </a:pPr>
             <a:r>
-              <a:rPr lang="en-US" sz="810" dirty="0">
+              <a:rPr lang="en-US" sz="780" dirty="0">
                 <a:solidFill>
                   <a:srgbClr val="5F7183"/>
                 </a:solidFill>
@@ -17313,7 +17467,7 @@
               </a:rPr>
               <a:t>Tiết 2 · 第 2 節</a:t>
             </a:r>
-            <a:endParaRPr lang="en-US" sz="810" dirty="0"/>
+            <a:endParaRPr lang="en-US" sz="780" dirty="0"/>
           </a:p>
         </p:txBody>
       </p:sp>

</xml_diff>

<commit_message>
Week 7 L2 slide 8: every fusion needs association; late fusion is where it takes judgement
Co-Authored-By: Claude Opus 5.5 <noreply@anthropic.com>
</commit_message>
<xml_diff>
--- a/第七週(10-22)/第七週_第2節_簡報.pptx
+++ b/第七週(10-22)/第七週_第2節_簡報.pptx
@@ -5928,11 +5928,11 @@
                 <a:spcPts val="0"/>
               </a:spcBef>
               <a:spcAft>
-                <a:spcPts val="225"/>
+                <a:spcPts val="175"/>
               </a:spcAft>
             </a:pPr>
             <a:r>
-              <a:rPr sz="1350" b="1" lang="zh-TW" dirty="0">
+              <a:rPr sz="1050" b="1" lang="zh-TW" dirty="0">
                 <a:solidFill>
                   <a:srgbClr val="000000"/>
                 </a:solidFill>
@@ -5943,15 +5943,15 @@
               <a:t>這一張的目的：</a:t>
             </a:r>
             <a:r>
-              <a:rPr sz="1350" lang="zh-TW" dirty="0">
-                <a:solidFill>
-                  <a:srgbClr val="000000"/>
-                </a:solidFill>
-                <a:latin typeface="Arial Unicode MS"/>
-                <a:ea typeface="Arial Unicode MS"/>
-                <a:cs typeface="Arial Unicode MS"/>
-              </a:rPr>
-              <a:t>讓大家知道，後期融合最關鍵的一步是「對應」，把雷達的點對到相機的框上。
+              <a:rPr sz="1050" lang="zh-TW" dirty="0">
+                <a:solidFill>
+                  <a:srgbClr val="000000"/>
+                </a:solidFill>
+                <a:latin typeface="Arial Unicode MS"/>
+                <a:ea typeface="Arial Unicode MS"/>
+                <a:cs typeface="Arial Unicode MS"/>
+              </a:rPr>
+              <a:t>讓大家知道，每一種融合都要先弄清楚「哪些資料講的是同一個東西」，這叫對應；後期融合的對應要靠判斷、最容易出錯，所以這一張拿它來講。
 </a:t>
             </a:r>
           </a:p>
@@ -5961,41 +5961,41 @@
                 <a:spcPts val="0"/>
               </a:spcBef>
               <a:spcAft>
-                <a:spcPts val="225"/>
+                <a:spcPts val="175"/>
               </a:spcAft>
             </a:pPr>
             <a:r>
-              <a:rPr sz="1350" lang="zh-TW" dirty="0">
-                <a:solidFill>
-                  <a:srgbClr val="000000"/>
-                </a:solidFill>
-                <a:latin typeface="Arial Unicode MS"/>
-                <a:ea typeface="Arial Unicode MS"/>
-                <a:cs typeface="Arial Unicode MS"/>
-              </a:rPr>
-              <a:t>後期融合最關鍵的一步，叫</a:t>
-            </a:r>
-            <a:r>
-              <a:rPr sz="1350" b="1" lang="zh-TW" dirty="0">
-                <a:solidFill>
-                  <a:srgbClr val="000000"/>
-                </a:solidFill>
-                <a:latin typeface="Arial Unicode MS"/>
-                <a:ea typeface="Arial Unicode MS"/>
-                <a:cs typeface="Arial Unicode MS"/>
-              </a:rPr>
-              <a:t>對應</a:t>
-            </a:r>
-            <a:r>
-              <a:rPr sz="1350" lang="zh-TW" dirty="0">
-                <a:solidFill>
-                  <a:srgbClr val="000000"/>
-                </a:solidFill>
-                <a:latin typeface="Arial Unicode MS"/>
-                <a:ea typeface="Arial Unicode MS"/>
-                <a:cs typeface="Arial Unicode MS"/>
-              </a:rPr>
-              <a:t>：雷達的這個點，跟相機的哪一個框，是同一個東西？
+              <a:rPr sz="1050" lang="zh-TW" dirty="0">
+                <a:solidFill>
+                  <a:srgbClr val="000000"/>
+                </a:solidFill>
+                <a:latin typeface="Arial Unicode MS"/>
+                <a:ea typeface="Arial Unicode MS"/>
+                <a:cs typeface="Arial Unicode MS"/>
+              </a:rPr>
+              <a:t>先講清楚：</a:t>
+            </a:r>
+            <a:r>
+              <a:rPr sz="1050" b="1" lang="zh-TW" dirty="0">
+                <a:solidFill>
+                  <a:srgbClr val="000000"/>
+                </a:solidFill>
+                <a:latin typeface="Arial Unicode MS"/>
+                <a:ea typeface="Arial Unicode MS"/>
+                <a:cs typeface="Arial Unicode MS"/>
+              </a:rPr>
+              <a:t>每一種融合都要對應</a:t>
+            </a:r>
+            <a:r>
+              <a:rPr sz="1050" lang="zh-TW" dirty="0">
+                <a:solidFill>
+                  <a:srgbClr val="000000"/>
+                </a:solidFill>
+                <a:latin typeface="Arial Unicode MS"/>
+                <a:ea typeface="Arial Unicode MS"/>
+                <a:cs typeface="Arial Unicode MS"/>
+              </a:rPr>
+              <a:t>，只是對的東西不一樣。
 </a:t>
             </a:r>
           </a:p>
@@ -6005,19 +6005,74 @@
                 <a:spcPts val="0"/>
               </a:spcBef>
               <a:spcAft>
-                <a:spcPts val="225"/>
+                <a:spcPts val="175"/>
               </a:spcAft>
             </a:pPr>
             <a:r>
-              <a:rPr sz="1350" lang="zh-TW" dirty="0">
-                <a:solidFill>
-                  <a:srgbClr val="000000"/>
-                </a:solidFill>
-                <a:latin typeface="Arial Unicode MS"/>
-                <a:ea typeface="Arial Unicode MS"/>
-                <a:cs typeface="Arial Unicode MS"/>
-              </a:rPr>
-              <a:t>就像拿到一張班級照片和一份名單，要把名字對到臉上。對錯了，「時速三十」就被安到另一台車身上。
+              <a:rPr sz="1050" b="1" lang="zh-TW" dirty="0">
+                <a:solidFill>
+                  <a:srgbClr val="000000"/>
+                </a:solidFill>
+                <a:latin typeface="Arial Unicode MS"/>
+                <a:ea typeface="Arial Unicode MS"/>
+                <a:cs typeface="Arial Unicode MS"/>
+              </a:rPr>
+              <a:t>前期融合</a:t>
+            </a:r>
+            <a:r>
+              <a:rPr sz="1050" lang="zh-TW" dirty="0">
+                <a:solidFill>
+                  <a:srgbClr val="000000"/>
+                </a:solidFill>
+                <a:latin typeface="Arial Unicode MS"/>
+                <a:ea typeface="Arial Unicode MS"/>
+                <a:cs typeface="Arial Unicode MS"/>
+              </a:rPr>
+              <a:t>，對的是一個點對一個像素。外參、內參標好了，光達的點落在照片的哪一個像素，是用公式</a:t>
+            </a:r>
+            <a:r>
+              <a:rPr sz="1050" b="1" lang="zh-TW" dirty="0">
+                <a:solidFill>
+                  <a:srgbClr val="000000"/>
+                </a:solidFill>
+                <a:latin typeface="Arial Unicode MS"/>
+                <a:ea typeface="Arial Unicode MS"/>
+                <a:cs typeface="Arial Unicode MS"/>
+              </a:rPr>
+              <a:t>算出來的</a:t>
+            </a:r>
+            <a:r>
+              <a:rPr sz="1050" lang="zh-TW" dirty="0">
+                <a:solidFill>
+                  <a:srgbClr val="000000"/>
+                </a:solidFill>
+                <a:latin typeface="Arial Unicode MS"/>
+                <a:ea typeface="Arial Unicode MS"/>
+                <a:cs typeface="Arial Unicode MS"/>
+              </a:rPr>
+              <a:t>，不用猜。</a:t>
+            </a:r>
+            <a:r>
+              <a:rPr sz="1050" b="1" lang="zh-TW" dirty="0">
+                <a:solidFill>
+                  <a:srgbClr val="000000"/>
+                </a:solidFill>
+                <a:latin typeface="Arial Unicode MS"/>
+                <a:ea typeface="Arial Unicode MS"/>
+                <a:cs typeface="Arial Unicode MS"/>
+              </a:rPr>
+              <a:t>中期融合</a:t>
+            </a:r>
+            <a:r>
+              <a:rPr sz="1050" lang="zh-TW" dirty="0">
+                <a:solidFill>
+                  <a:srgbClr val="000000"/>
+                </a:solidFill>
+                <a:latin typeface="Arial Unicode MS"/>
+                <a:ea typeface="Arial Unicode MS"/>
+                <a:cs typeface="Arial Unicode MS"/>
+              </a:rPr>
+              <a:t>，對的是一格對一格。大家都畫到同一張鳥瞰圖上，同一格就是地上同一塊，也是算出來的，剩下的交給訓練好的網路。
 </a:t>
             </a:r>
           </a:p>
@@ -6027,63 +6082,52 @@
                 <a:spcPts val="0"/>
               </a:spcBef>
               <a:spcAft>
-                <a:spcPts val="225"/>
+                <a:spcPts val="175"/>
               </a:spcAft>
             </a:pPr>
             <a:r>
-              <a:rPr sz="1350" lang="zh-TW" dirty="0">
-                <a:solidFill>
-                  <a:srgbClr val="000000"/>
-                </a:solidFill>
-                <a:latin typeface="Arial Unicode MS"/>
-                <a:ea typeface="Arial Unicode MS"/>
-                <a:cs typeface="Arial Unicode MS"/>
-              </a:rPr>
-              <a:t>看左圖，波士頓的一條街。框是官方標註的物體，紅圈是雷達點。</a:t>
-            </a:r>
-            <a:r>
-              <a:rPr sz="1350" b="1" lang="zh-TW" dirty="0">
-                <a:solidFill>
-                  <a:srgbClr val="000000"/>
-                </a:solidFill>
-                <a:latin typeface="Arial Unicode MS"/>
-                <a:ea typeface="Arial Unicode MS"/>
-                <a:cs typeface="Arial Unicode MS"/>
-              </a:rPr>
-              <a:t>綠框</a:t>
-            </a:r>
-            <a:r>
-              <a:rPr sz="1350" lang="zh-TW" dirty="0">
-                <a:solidFill>
-                  <a:srgbClr val="000000"/>
-                </a:solidFill>
-                <a:latin typeface="Arial Unicode MS"/>
-                <a:ea typeface="Arial Unicode MS"/>
-                <a:cs typeface="Arial Unicode MS"/>
-              </a:rPr>
-              <a:t>，是框裡至少有一個雷達點的：路邊停的那幾台車，框裡都有紅圈。</a:t>
-            </a:r>
-            <a:r>
-              <a:rPr sz="1350" b="1" lang="zh-TW" dirty="0">
-                <a:solidFill>
-                  <a:srgbClr val="000000"/>
-                </a:solidFill>
-                <a:latin typeface="Arial Unicode MS"/>
-                <a:ea typeface="Arial Unicode MS"/>
-                <a:cs typeface="Arial Unicode MS"/>
-              </a:rPr>
-              <a:t>黃框</a:t>
-            </a:r>
-            <a:r>
-              <a:rPr sz="1350" lang="zh-TW" dirty="0">
-                <a:solidFill>
-                  <a:srgbClr val="000000"/>
-                </a:solidFill>
-                <a:latin typeface="Arial Unicode MS"/>
-                <a:ea typeface="Arial Unicode MS"/>
-                <a:cs typeface="Arial Unicode MS"/>
-              </a:rPr>
-              <a:t>，是一個雷達點都沒有的：四個行人，和好幾台遠處的車，大多在四十五公尺以外。這跟上一節那張統計表一樣：雷達抓得到近處的車，抓不太到人，車子一遠也開始漏。
+              <a:rPr sz="1050" b="1" lang="zh-TW" dirty="0">
+                <a:solidFill>
+                  <a:srgbClr val="000000"/>
+                </a:solidFill>
+                <a:latin typeface="Arial Unicode MS"/>
+                <a:ea typeface="Arial Unicode MS"/>
+                <a:cs typeface="Arial Unicode MS"/>
+              </a:rPr>
+              <a:t>後期融合</a:t>
+            </a:r>
+            <a:r>
+              <a:rPr sz="1050" lang="zh-TW" dirty="0">
+                <a:solidFill>
+                  <a:srgbClr val="000000"/>
+                </a:solidFill>
+                <a:latin typeface="Arial Unicode MS"/>
+                <a:ea typeface="Arial Unicode MS"/>
+                <a:cs typeface="Arial Unicode MS"/>
+              </a:rPr>
+              <a:t>不一樣。相機交出一張框的清單，雷達交出一張目標的清單，兩張清單上的東西誰配誰，沒有公式可以直接算，要</a:t>
+            </a:r>
+            <a:r>
+              <a:rPr sz="1050" b="1" lang="zh-TW" dirty="0">
+                <a:solidFill>
+                  <a:srgbClr val="000000"/>
+                </a:solidFill>
+                <a:latin typeface="Arial Unicode MS"/>
+                <a:ea typeface="Arial Unicode MS"/>
+                <a:cs typeface="Arial Unicode MS"/>
+              </a:rPr>
+              <a:t>判斷</a:t>
+            </a:r>
+            <a:r>
+              <a:rPr sz="1050" lang="zh-TW" dirty="0">
+                <a:solidFill>
+                  <a:srgbClr val="000000"/>
+                </a:solidFill>
+                <a:latin typeface="Arial Unicode MS"/>
+                <a:ea typeface="Arial Unicode MS"/>
+                <a:cs typeface="Arial Unicode MS"/>
+              </a:rPr>
+              <a:t>。兩台車靠得很近、雷達點剛好落在兩個框中間、路邊多出一排不屬於任何框的點，都要做決定。所以對應在後期融合最明顯，也最容易出錯。
 </a:t>
             </a:r>
           </a:p>
@@ -6093,41 +6137,41 @@
                 <a:spcPts val="0"/>
               </a:spcBef>
               <a:spcAft>
-                <a:spcPts val="225"/>
+                <a:spcPts val="175"/>
               </a:spcAft>
             </a:pPr>
             <a:r>
-              <a:rPr sz="1350" lang="zh-TW" dirty="0">
-                <a:solidFill>
-                  <a:srgbClr val="000000"/>
-                </a:solidFill>
-                <a:latin typeface="Arial Unicode MS"/>
-                <a:ea typeface="Arial Unicode MS"/>
-                <a:cs typeface="Arial Unicode MS"/>
-              </a:rPr>
-              <a:t>再看路的右邊，有一長排紅圈，排在人行道旁邊，沒有任何框。那多半是路邊的東西，可能是欄杆、樹、號誌桿。這些點不屬於任何一台標註的物體，對應的時候要</a:t>
-            </a:r>
-            <a:r>
-              <a:rPr sz="1350" b="1" lang="zh-TW" dirty="0">
-                <a:solidFill>
-                  <a:srgbClr val="000000"/>
-                </a:solidFill>
-                <a:latin typeface="Arial Unicode MS"/>
-                <a:ea typeface="Arial Unicode MS"/>
-                <a:cs typeface="Arial Unicode MS"/>
-              </a:rPr>
-              <a:t>正確地丟掉</a:t>
-            </a:r>
-            <a:r>
-              <a:rPr sz="1350" lang="zh-TW" dirty="0">
-                <a:solidFill>
-                  <a:srgbClr val="000000"/>
-                </a:solidFill>
-                <a:latin typeface="Arial Unicode MS"/>
-                <a:ea typeface="Arial Unicode MS"/>
-                <a:cs typeface="Arial Unicode MS"/>
-              </a:rPr>
-              <a:t>，不然就變成上一節講的幽靈煞車。
+              <a:rPr sz="1050" lang="zh-TW" dirty="0">
+                <a:solidFill>
+                  <a:srgbClr val="000000"/>
+                </a:solidFill>
+                <a:latin typeface="Arial Unicode MS"/>
+                <a:ea typeface="Arial Unicode MS"/>
+                <a:cs typeface="Arial Unicode MS"/>
+              </a:rPr>
+              <a:t>還有一種對應，每一種融合都逃不掉：</a:t>
+            </a:r>
+            <a:r>
+              <a:rPr sz="1050" b="1" lang="zh-TW" dirty="0">
+                <a:solidFill>
+                  <a:srgbClr val="000000"/>
+                </a:solidFill>
+                <a:latin typeface="Arial Unicode MS"/>
+                <a:ea typeface="Arial Unicode MS"/>
+                <a:cs typeface="Arial Unicode MS"/>
+              </a:rPr>
+              <a:t>前後兩格之間</a:t>
+            </a:r>
+            <a:r>
+              <a:rPr sz="1050" lang="zh-TW" dirty="0">
+                <a:solidFill>
+                  <a:srgbClr val="000000"/>
+                </a:solidFill>
+                <a:latin typeface="Arial Unicode MS"/>
+                <a:ea typeface="Arial Unicode MS"/>
+                <a:cs typeface="Arial Unicode MS"/>
+              </a:rPr>
+              <a:t>。這一格的這台車，是不是上一格那一台？這叫追蹤，第三節任務五的第 13 題會用到。
 </a:t>
             </a:r>
           </a:p>
@@ -6137,63 +6181,19 @@
                 <a:spcPts val="0"/>
               </a:spcBef>
               <a:spcAft>
-                <a:spcPts val="225"/>
+                <a:spcPts val="175"/>
               </a:spcAft>
             </a:pPr>
             <a:r>
-              <a:rPr sz="1350" lang="zh-TW" dirty="0">
-                <a:solidFill>
-                  <a:srgbClr val="000000"/>
-                </a:solidFill>
-                <a:latin typeface="Arial Unicode MS"/>
-                <a:ea typeface="Arial Unicode MS"/>
-                <a:cs typeface="Arial Unicode MS"/>
-              </a:rPr>
-              <a:t>怎麼對？最簡單的就是看</a:t>
-            </a:r>
-            <a:r>
-              <a:rPr sz="1350" b="1" lang="zh-TW" dirty="0">
-                <a:solidFill>
-                  <a:srgbClr val="000000"/>
-                </a:solidFill>
-                <a:latin typeface="Arial Unicode MS"/>
-                <a:ea typeface="Arial Unicode MS"/>
-                <a:cs typeface="Arial Unicode MS"/>
-              </a:rPr>
-              <a:t>位置</a:t>
-            </a:r>
-            <a:r>
-              <a:rPr sz="1350" lang="zh-TW" dirty="0">
-                <a:solidFill>
-                  <a:srgbClr val="000000"/>
-                </a:solidFill>
-                <a:latin typeface="Arial Unicode MS"/>
-                <a:ea typeface="Arial Unicode MS"/>
-                <a:cs typeface="Arial Unicode MS"/>
-              </a:rPr>
-              <a:t>：雷達點落在哪個框附近，就算它的。再加上</a:t>
-            </a:r>
-            <a:r>
-              <a:rPr sz="1350" b="1" lang="zh-TW" dirty="0">
-                <a:solidFill>
-                  <a:srgbClr val="000000"/>
-                </a:solidFill>
-                <a:latin typeface="Arial Unicode MS"/>
-                <a:ea typeface="Arial Unicode MS"/>
-                <a:cs typeface="Arial Unicode MS"/>
-              </a:rPr>
-              <a:t>速度</a:t>
-            </a:r>
-            <a:r>
-              <a:rPr sz="1350" lang="zh-TW" dirty="0">
-                <a:solidFill>
-                  <a:srgbClr val="000000"/>
-                </a:solidFill>
-                <a:latin typeface="Arial Unicode MS"/>
-                <a:ea typeface="Arial Unicode MS"/>
-                <a:cs typeface="Arial Unicode MS"/>
-              </a:rPr>
-              <a:t>：雷達量得到速度，一個靜止的點，不會是一台正在開的車。
+              <a:rPr sz="1050" lang="zh-TW" dirty="0">
+                <a:solidFill>
+                  <a:srgbClr val="000000"/>
+                </a:solidFill>
+                <a:latin typeface="Arial Unicode MS"/>
+                <a:ea typeface="Arial Unicode MS"/>
+                <a:cs typeface="Arial Unicode MS"/>
+              </a:rPr>
+              <a:t>回到後期融合：雷達的這個點，跟相機的哪一個框，是同一個東西？
 </a:t>
             </a:r>
           </a:p>
@@ -6203,11 +6203,209 @@
                 <a:spcPts val="0"/>
               </a:spcBef>
               <a:spcAft>
-                <a:spcPts val="225"/>
+                <a:spcPts val="175"/>
               </a:spcAft>
             </a:pPr>
             <a:r>
-              <a:rPr sz="1350" lang="zh-TW" dirty="0">
+              <a:rPr sz="1050" lang="zh-TW" dirty="0">
+                <a:solidFill>
+                  <a:srgbClr val="000000"/>
+                </a:solidFill>
+                <a:latin typeface="Arial Unicode MS"/>
+                <a:ea typeface="Arial Unicode MS"/>
+                <a:cs typeface="Arial Unicode MS"/>
+              </a:rPr>
+              <a:t>就像拿到一張班級照片和一份名單，要把名字對到臉上。對錯了，「時速三十」就被安到另一台車身上。
+</a:t>
+            </a:r>
+          </a:p>
+          <a:p>
+            <a:pPr algn="l">
+              <a:spcBef>
+                <a:spcPts val="0"/>
+              </a:spcBef>
+              <a:spcAft>
+                <a:spcPts val="175"/>
+              </a:spcAft>
+            </a:pPr>
+            <a:r>
+              <a:rPr sz="1050" lang="zh-TW" dirty="0">
+                <a:solidFill>
+                  <a:srgbClr val="000000"/>
+                </a:solidFill>
+                <a:latin typeface="Arial Unicode MS"/>
+                <a:ea typeface="Arial Unicode MS"/>
+                <a:cs typeface="Arial Unicode MS"/>
+              </a:rPr>
+              <a:t>看左圖，波士頓的一條街。框是官方標註的物體，紅圈是雷達點。</a:t>
+            </a:r>
+            <a:r>
+              <a:rPr sz="1050" b="1" lang="zh-TW" dirty="0">
+                <a:solidFill>
+                  <a:srgbClr val="000000"/>
+                </a:solidFill>
+                <a:latin typeface="Arial Unicode MS"/>
+                <a:ea typeface="Arial Unicode MS"/>
+                <a:cs typeface="Arial Unicode MS"/>
+              </a:rPr>
+              <a:t>綠框</a:t>
+            </a:r>
+            <a:r>
+              <a:rPr sz="1050" lang="zh-TW" dirty="0">
+                <a:solidFill>
+                  <a:srgbClr val="000000"/>
+                </a:solidFill>
+                <a:latin typeface="Arial Unicode MS"/>
+                <a:ea typeface="Arial Unicode MS"/>
+                <a:cs typeface="Arial Unicode MS"/>
+              </a:rPr>
+              <a:t>，是框裡至少有一個雷達點的：路邊停的那幾台車，框裡都有紅圈。</a:t>
+            </a:r>
+            <a:r>
+              <a:rPr sz="1050" b="1" lang="zh-TW" dirty="0">
+                <a:solidFill>
+                  <a:srgbClr val="000000"/>
+                </a:solidFill>
+                <a:latin typeface="Arial Unicode MS"/>
+                <a:ea typeface="Arial Unicode MS"/>
+                <a:cs typeface="Arial Unicode MS"/>
+              </a:rPr>
+              <a:t>黃框</a:t>
+            </a:r>
+            <a:r>
+              <a:rPr sz="1050" lang="zh-TW" dirty="0">
+                <a:solidFill>
+                  <a:srgbClr val="000000"/>
+                </a:solidFill>
+                <a:latin typeface="Arial Unicode MS"/>
+                <a:ea typeface="Arial Unicode MS"/>
+                <a:cs typeface="Arial Unicode MS"/>
+              </a:rPr>
+              <a:t>，是一個雷達點都沒有的：四個行人，和好幾台遠處的車，大多在四十五公尺以外。這跟上一節那張統計表一樣：雷達抓得到近處的車，抓不太到人，車子一遠也開始漏。
+</a:t>
+            </a:r>
+          </a:p>
+          <a:p>
+            <a:pPr algn="l">
+              <a:spcBef>
+                <a:spcPts val="0"/>
+              </a:spcBef>
+              <a:spcAft>
+                <a:spcPts val="175"/>
+              </a:spcAft>
+            </a:pPr>
+            <a:r>
+              <a:rPr sz="1050" lang="zh-TW" dirty="0">
+                <a:solidFill>
+                  <a:srgbClr val="000000"/>
+                </a:solidFill>
+                <a:latin typeface="Arial Unicode MS"/>
+                <a:ea typeface="Arial Unicode MS"/>
+                <a:cs typeface="Arial Unicode MS"/>
+              </a:rPr>
+              <a:t>再看路的右邊，有一長排紅圈，排在人行道旁邊，沒有任何框。那多半是路邊的東西，可能是欄杆、樹、號誌桿。這些點不屬於任何一台標註的物體，對應的時候要</a:t>
+            </a:r>
+            <a:r>
+              <a:rPr sz="1050" b="1" lang="zh-TW" dirty="0">
+                <a:solidFill>
+                  <a:srgbClr val="000000"/>
+                </a:solidFill>
+                <a:latin typeface="Arial Unicode MS"/>
+                <a:ea typeface="Arial Unicode MS"/>
+                <a:cs typeface="Arial Unicode MS"/>
+              </a:rPr>
+              <a:t>正確地丟掉</a:t>
+            </a:r>
+            <a:r>
+              <a:rPr sz="1050" lang="zh-TW" dirty="0">
+                <a:solidFill>
+                  <a:srgbClr val="000000"/>
+                </a:solidFill>
+                <a:latin typeface="Arial Unicode MS"/>
+                <a:ea typeface="Arial Unicode MS"/>
+                <a:cs typeface="Arial Unicode MS"/>
+              </a:rPr>
+              <a:t>，不然就變成上一節講的幽靈煞車。
+</a:t>
+            </a:r>
+          </a:p>
+          <a:p>
+            <a:pPr algn="l">
+              <a:spcBef>
+                <a:spcPts val="0"/>
+              </a:spcBef>
+              <a:spcAft>
+                <a:spcPts val="175"/>
+              </a:spcAft>
+            </a:pPr>
+            <a:r>
+              <a:rPr sz="1050" lang="zh-TW" dirty="0">
+                <a:solidFill>
+                  <a:srgbClr val="000000"/>
+                </a:solidFill>
+                <a:latin typeface="Arial Unicode MS"/>
+                <a:ea typeface="Arial Unicode MS"/>
+                <a:cs typeface="Arial Unicode MS"/>
+              </a:rPr>
+              <a:t>怎麼對？最簡單的就是看</a:t>
+            </a:r>
+            <a:r>
+              <a:rPr sz="1050" b="1" lang="zh-TW" dirty="0">
+                <a:solidFill>
+                  <a:srgbClr val="000000"/>
+                </a:solidFill>
+                <a:latin typeface="Arial Unicode MS"/>
+                <a:ea typeface="Arial Unicode MS"/>
+                <a:cs typeface="Arial Unicode MS"/>
+              </a:rPr>
+              <a:t>位置</a:t>
+            </a:r>
+            <a:r>
+              <a:rPr sz="1050" lang="zh-TW" dirty="0">
+                <a:solidFill>
+                  <a:srgbClr val="000000"/>
+                </a:solidFill>
+                <a:latin typeface="Arial Unicode MS"/>
+                <a:ea typeface="Arial Unicode MS"/>
+                <a:cs typeface="Arial Unicode MS"/>
+              </a:rPr>
+              <a:t>：雷達點落在哪個框附近，就算它的。再加上</a:t>
+            </a:r>
+            <a:r>
+              <a:rPr sz="1050" b="1" lang="zh-TW" dirty="0">
+                <a:solidFill>
+                  <a:srgbClr val="000000"/>
+                </a:solidFill>
+                <a:latin typeface="Arial Unicode MS"/>
+                <a:ea typeface="Arial Unicode MS"/>
+                <a:cs typeface="Arial Unicode MS"/>
+              </a:rPr>
+              <a:t>速度</a:t>
+            </a:r>
+            <a:r>
+              <a:rPr sz="1050" lang="zh-TW" dirty="0">
+                <a:solidFill>
+                  <a:srgbClr val="000000"/>
+                </a:solidFill>
+                <a:latin typeface="Arial Unicode MS"/>
+                <a:ea typeface="Arial Unicode MS"/>
+                <a:cs typeface="Arial Unicode MS"/>
+              </a:rPr>
+              <a:t>：雷達量得到速度，一個靜止的點，不會是一台正在開的車。
+</a:t>
+            </a:r>
+          </a:p>
+          <a:p>
+            <a:pPr algn="l">
+              <a:spcBef>
+                <a:spcPts val="0"/>
+              </a:spcBef>
+              <a:spcAft>
+                <a:spcPts val="175"/>
+              </a:spcAft>
+            </a:pPr>
+            <a:r>
+              <a:rPr sz="1050" lang="zh-TW" dirty="0">
                 <a:solidFill>
                   <a:srgbClr val="000000"/>
                 </a:solidFill>
@@ -6218,7 +6416,7 @@
               <a:t>看一支影片，NVIDIA 做自駕晶片的團隊。</a:t>
             </a:r>
             <a:r>
-              <a:rPr sz="1350" b="1" lang="zh-TW" dirty="0">
+              <a:rPr sz="1050" b="1" lang="zh-TW" dirty="0">
                 <a:solidFill>
                   <a:srgbClr val="000000"/>
                 </a:solidFill>
@@ -6229,7 +6427,7 @@
               <a:t>從 0:42 播到 1:30。</a:t>
             </a:r>
             <a:r>
-              <a:rPr sz="1350" lang="zh-TW" dirty="0">
+              <a:rPr sz="1050" lang="zh-TW" dirty="0">
                 <a:solidFill>
                   <a:srgbClr val="000000"/>
                 </a:solidFill>
@@ -6240,7 +6438,7 @@
               <a:t>英文，我邊播邊講。畫面是車子周圍幾台相機拼起來的；</a:t>
             </a:r>
             <a:r>
-              <a:rPr sz="1350" b="1" lang="zh-TW" dirty="0">
+              <a:rPr sz="1050" b="1" lang="zh-TW" dirty="0">
                 <a:solidFill>
                   <a:srgbClr val="000000"/>
                 </a:solidFill>
@@ -6251,7 +6449,7 @@
               <a:t>0:47 小白方塊是雷達追蹤到的目標，橘色的線是它走過的路</a:t>
             </a:r>
             <a:r>
-              <a:rPr sz="1350" lang="zh-TW" dirty="0">
+              <a:rPr sz="1050" lang="zh-TW" dirty="0">
                 <a:solidFill>
                   <a:srgbClr val="000000"/>
                 </a:solidFill>
@@ -6262,7 +6460,7 @@
               <a:t>。</a:t>
             </a:r>
             <a:r>
-              <a:rPr sz="1350" b="1" lang="zh-TW" dirty="0">
+              <a:rPr sz="1050" b="1" lang="zh-TW" dirty="0">
                 <a:solidFill>
                   <a:srgbClr val="000000"/>
                 </a:solidFill>
@@ -6273,7 +6471,7 @@
               <a:t>0:52</a:t>
             </a:r>
             <a:r>
-              <a:rPr sz="1350" lang="zh-TW" dirty="0">
+              <a:rPr sz="1050" lang="zh-TW" dirty="0">
                 <a:solidFill>
                   <a:srgbClr val="000000"/>
                 </a:solidFill>
@@ -6284,7 +6482,7 @@
               <a:t> 旁白說：相機框出來的物體，和雷達的目標對上之後，小方塊會變成綠色。</a:t>
             </a:r>
             <a:r>
-              <a:rPr sz="1350" b="1" lang="zh-TW" dirty="0">
+              <a:rPr sz="1050" b="1" lang="zh-TW" dirty="0">
                 <a:solidFill>
                   <a:srgbClr val="000000"/>
                 </a:solidFill>
@@ -6295,7 +6493,7 @@
               <a:t>0:58</a:t>
             </a:r>
             <a:r>
-              <a:rPr sz="1350" lang="zh-TW" dirty="0">
+              <a:rPr sz="1050" lang="zh-TW" dirty="0">
                 <a:solidFill>
                   <a:srgbClr val="000000"/>
                 </a:solidFill>
@@ -6306,7 +6504,7 @@
               <a:t> 旁白講了融合的好處：位置、速度、加速度，都變得更準、更可靠。</a:t>
             </a:r>
             <a:r>
-              <a:rPr sz="1350" b="1" lang="zh-TW" dirty="0">
+              <a:rPr sz="1050" b="1" lang="zh-TW" dirty="0">
                 <a:solidFill>
                   <a:srgbClr val="000000"/>
                 </a:solidFill>
@@ -6317,7 +6515,7 @@
               <a:t>1:10</a:t>
             </a:r>
             <a:r>
-              <a:rPr sz="1350" lang="zh-TW" dirty="0">
+              <a:rPr sz="1050" lang="zh-TW" dirty="0">
                 <a:solidFill>
                   <a:srgbClr val="000000"/>
                 </a:solidFill>

</xml_diff>

<commit_message>
Week 7 L2 slide 8: late fusion matches radar targets to camera boxes (object to object)
Co-Authored-By: Claude Opus 5.5 <noreply@anthropic.com>
</commit_message>
<xml_diff>
--- a/第七週(10-22)/第七週_第2節_簡報.pptx
+++ b/第七週(10-22)/第七週_第2節_簡報.pptx
@@ -5928,11 +5928,11 @@
                 <a:spcPts val="0"/>
               </a:spcBef>
               <a:spcAft>
-                <a:spcPts val="175"/>
+                <a:spcPts val="150"/>
               </a:spcAft>
             </a:pPr>
             <a:r>
-              <a:rPr sz="1050" b="1" lang="zh-TW" dirty="0">
+              <a:rPr sz="900" b="1" lang="zh-TW" dirty="0">
                 <a:solidFill>
                   <a:srgbClr val="000000"/>
                 </a:solidFill>
@@ -5943,7 +5943,7 @@
               <a:t>這一張的目的：</a:t>
             </a:r>
             <a:r>
-              <a:rPr sz="1050" lang="zh-TW" dirty="0">
+              <a:rPr sz="900" lang="zh-TW" dirty="0">
                 <a:solidFill>
                   <a:srgbClr val="000000"/>
                 </a:solidFill>
@@ -5961,11 +5961,11 @@
                 <a:spcPts val="0"/>
               </a:spcBef>
               <a:spcAft>
-                <a:spcPts val="175"/>
+                <a:spcPts val="150"/>
               </a:spcAft>
             </a:pPr>
             <a:r>
-              <a:rPr sz="1050" lang="zh-TW" dirty="0">
+              <a:rPr sz="900" lang="zh-TW" dirty="0">
                 <a:solidFill>
                   <a:srgbClr val="000000"/>
                 </a:solidFill>
@@ -5976,7 +5976,7 @@
               <a:t>先講清楚：</a:t>
             </a:r>
             <a:r>
-              <a:rPr sz="1050" b="1" lang="zh-TW" dirty="0">
+              <a:rPr sz="900" b="1" lang="zh-TW" dirty="0">
                 <a:solidFill>
                   <a:srgbClr val="000000"/>
                 </a:solidFill>
@@ -5987,7 +5987,7 @@
               <a:t>每一種融合都要對應</a:t>
             </a:r>
             <a:r>
-              <a:rPr sz="1050" lang="zh-TW" dirty="0">
+              <a:rPr sz="900" lang="zh-TW" dirty="0">
                 <a:solidFill>
                   <a:srgbClr val="000000"/>
                 </a:solidFill>
@@ -6005,11 +6005,11 @@
                 <a:spcPts val="0"/>
               </a:spcBef>
               <a:spcAft>
-                <a:spcPts val="175"/>
+                <a:spcPts val="150"/>
               </a:spcAft>
             </a:pPr>
             <a:r>
-              <a:rPr sz="1050" b="1" lang="zh-TW" dirty="0">
+              <a:rPr sz="900" b="1" lang="zh-TW" dirty="0">
                 <a:solidFill>
                   <a:srgbClr val="000000"/>
                 </a:solidFill>
@@ -6020,7 +6020,7 @@
               <a:t>前期融合</a:t>
             </a:r>
             <a:r>
-              <a:rPr sz="1050" lang="zh-TW" dirty="0">
+              <a:rPr sz="900" lang="zh-TW" dirty="0">
                 <a:solidFill>
                   <a:srgbClr val="000000"/>
                 </a:solidFill>
@@ -6031,7 +6031,7 @@
               <a:t>，對的是一個點對一個像素。外參、內參標好了，光達的點落在照片的哪一個像素，是用公式</a:t>
             </a:r>
             <a:r>
-              <a:rPr sz="1050" b="1" lang="zh-TW" dirty="0">
+              <a:rPr sz="900" b="1" lang="zh-TW" dirty="0">
                 <a:solidFill>
                   <a:srgbClr val="000000"/>
                 </a:solidFill>
@@ -6042,7 +6042,7 @@
               <a:t>算出來的</a:t>
             </a:r>
             <a:r>
-              <a:rPr sz="1050" lang="zh-TW" dirty="0">
+              <a:rPr sz="900" lang="zh-TW" dirty="0">
                 <a:solidFill>
                   <a:srgbClr val="000000"/>
                 </a:solidFill>
@@ -6053,7 +6053,7 @@
               <a:t>，不用猜。</a:t>
             </a:r>
             <a:r>
-              <a:rPr sz="1050" b="1" lang="zh-TW" dirty="0">
+              <a:rPr sz="900" b="1" lang="zh-TW" dirty="0">
                 <a:solidFill>
                   <a:srgbClr val="000000"/>
                 </a:solidFill>
@@ -6064,7 +6064,7 @@
               <a:t>中期融合</a:t>
             </a:r>
             <a:r>
-              <a:rPr sz="1050" lang="zh-TW" dirty="0">
+              <a:rPr sz="900" lang="zh-TW" dirty="0">
                 <a:solidFill>
                   <a:srgbClr val="000000"/>
                 </a:solidFill>
@@ -6082,11 +6082,11 @@
                 <a:spcPts val="0"/>
               </a:spcBef>
               <a:spcAft>
-                <a:spcPts val="175"/>
+                <a:spcPts val="150"/>
               </a:spcAft>
             </a:pPr>
             <a:r>
-              <a:rPr sz="1050" b="1" lang="zh-TW" dirty="0">
+              <a:rPr sz="900" b="1" lang="zh-TW" dirty="0">
                 <a:solidFill>
                   <a:srgbClr val="000000"/>
                 </a:solidFill>
@@ -6097,7 +6097,7 @@
               <a:t>後期融合</a:t>
             </a:r>
             <a:r>
-              <a:rPr sz="1050" lang="zh-TW" dirty="0">
+              <a:rPr sz="900" lang="zh-TW" dirty="0">
                 <a:solidFill>
                   <a:srgbClr val="000000"/>
                 </a:solidFill>
@@ -6108,7 +6108,7 @@
               <a:t>不一樣。相機交出一張框的清單，雷達交出一張目標的清單，兩張清單上的東西誰配誰，沒有公式可以直接算，要</a:t>
             </a:r>
             <a:r>
-              <a:rPr sz="1050" b="1" lang="zh-TW" dirty="0">
+              <a:rPr sz="900" b="1" lang="zh-TW" dirty="0">
                 <a:solidFill>
                   <a:srgbClr val="000000"/>
                 </a:solidFill>
@@ -6119,7 +6119,7 @@
               <a:t>判斷</a:t>
             </a:r>
             <a:r>
-              <a:rPr sz="1050" lang="zh-TW" dirty="0">
+              <a:rPr sz="900" lang="zh-TW" dirty="0">
                 <a:solidFill>
                   <a:srgbClr val="000000"/>
                 </a:solidFill>
@@ -6137,11 +6137,11 @@
                 <a:spcPts val="0"/>
               </a:spcBef>
               <a:spcAft>
-                <a:spcPts val="175"/>
+                <a:spcPts val="150"/>
               </a:spcAft>
             </a:pPr>
             <a:r>
-              <a:rPr sz="1050" lang="zh-TW" dirty="0">
+              <a:rPr sz="900" lang="zh-TW" dirty="0">
                 <a:solidFill>
                   <a:srgbClr val="000000"/>
                 </a:solidFill>
@@ -6152,7 +6152,7 @@
               <a:t>還有一種對應，每一種融合都逃不掉：</a:t>
             </a:r>
             <a:r>
-              <a:rPr sz="1050" b="1" lang="zh-TW" dirty="0">
+              <a:rPr sz="900" b="1" lang="zh-TW" dirty="0">
                 <a:solidFill>
                   <a:srgbClr val="000000"/>
                 </a:solidFill>
@@ -6163,7 +6163,7 @@
               <a:t>前後兩格之間</a:t>
             </a:r>
             <a:r>
-              <a:rPr sz="1050" lang="zh-TW" dirty="0">
+              <a:rPr sz="900" lang="zh-TW" dirty="0">
                 <a:solidFill>
                   <a:srgbClr val="000000"/>
                 </a:solidFill>
@@ -6181,19 +6181,63 @@
                 <a:spcPts val="0"/>
               </a:spcBef>
               <a:spcAft>
-                <a:spcPts val="175"/>
+                <a:spcPts val="150"/>
               </a:spcAft>
             </a:pPr>
             <a:r>
-              <a:rPr sz="1050" lang="zh-TW" dirty="0">
-                <a:solidFill>
-                  <a:srgbClr val="000000"/>
-                </a:solidFill>
-                <a:latin typeface="Arial Unicode MS"/>
-                <a:ea typeface="Arial Unicode MS"/>
-                <a:cs typeface="Arial Unicode MS"/>
-              </a:rPr>
-              <a:t>回到後期融合：雷達的這個點，跟相機的哪一個框，是同一個東西？
+              <a:rPr sz="900" lang="zh-TW" dirty="0">
+                <a:solidFill>
+                  <a:srgbClr val="000000"/>
+                </a:solidFill>
+                <a:latin typeface="Arial Unicode MS"/>
+                <a:ea typeface="Arial Unicode MS"/>
+                <a:cs typeface="Arial Unicode MS"/>
+              </a:rPr>
+              <a:t>回到後期融合：雷達清單上的這個</a:t>
+            </a:r>
+            <a:r>
+              <a:rPr sz="900" b="1" lang="zh-TW" dirty="0">
+                <a:solidFill>
+                  <a:srgbClr val="000000"/>
+                </a:solidFill>
+                <a:latin typeface="Arial Unicode MS"/>
+                <a:ea typeface="Arial Unicode MS"/>
+                <a:cs typeface="Arial Unicode MS"/>
+              </a:rPr>
+              <a:t>目標</a:t>
+            </a:r>
+            <a:r>
+              <a:rPr sz="900" lang="zh-TW" dirty="0">
+                <a:solidFill>
+                  <a:srgbClr val="000000"/>
+                </a:solidFill>
+                <a:latin typeface="Arial Unicode MS"/>
+                <a:ea typeface="Arial Unicode MS"/>
+                <a:cs typeface="Arial Unicode MS"/>
+              </a:rPr>
+              <a:t>，跟相機清單上的哪一個</a:t>
+            </a:r>
+            <a:r>
+              <a:rPr sz="900" b="1" lang="zh-TW" dirty="0">
+                <a:solidFill>
+                  <a:srgbClr val="000000"/>
+                </a:solidFill>
+                <a:latin typeface="Arial Unicode MS"/>
+                <a:ea typeface="Arial Unicode MS"/>
+                <a:cs typeface="Arial Unicode MS"/>
+              </a:rPr>
+              <a:t>框</a:t>
+            </a:r>
+            <a:r>
+              <a:rPr sz="900" lang="zh-TW" dirty="0">
+                <a:solidFill>
+                  <a:srgbClr val="000000"/>
+                </a:solidFill>
+                <a:latin typeface="Arial Unicode MS"/>
+                <a:ea typeface="Arial Unicode MS"/>
+                <a:cs typeface="Arial Unicode MS"/>
+              </a:rPr>
+              <a:t>，是同一個東西？兩邊都已經是物體了，所以是物體對物體。
 </a:t>
             </a:r>
           </a:p>
@@ -6203,11 +6247,11 @@
                 <a:spcPts val="0"/>
               </a:spcBef>
               <a:spcAft>
-                <a:spcPts val="175"/>
+                <a:spcPts val="150"/>
               </a:spcAft>
             </a:pPr>
             <a:r>
-              <a:rPr sz="1050" lang="zh-TW" dirty="0">
+              <a:rPr sz="900" lang="zh-TW" dirty="0">
                 <a:solidFill>
                   <a:srgbClr val="000000"/>
                 </a:solidFill>
@@ -6225,63 +6269,41 @@
                 <a:spcPts val="0"/>
               </a:spcBef>
               <a:spcAft>
-                <a:spcPts val="175"/>
+                <a:spcPts val="150"/>
               </a:spcAft>
             </a:pPr>
             <a:r>
-              <a:rPr sz="1050" lang="zh-TW" dirty="0">
-                <a:solidFill>
-                  <a:srgbClr val="000000"/>
-                </a:solidFill>
-                <a:latin typeface="Arial Unicode MS"/>
-                <a:ea typeface="Arial Unicode MS"/>
-                <a:cs typeface="Arial Unicode MS"/>
-              </a:rPr>
-              <a:t>看左圖，波士頓的一條街。框是官方標註的物體，紅圈是雷達點。</a:t>
-            </a:r>
-            <a:r>
-              <a:rPr sz="1050" b="1" lang="zh-TW" dirty="0">
-                <a:solidFill>
-                  <a:srgbClr val="000000"/>
-                </a:solidFill>
-                <a:latin typeface="Arial Unicode MS"/>
-                <a:ea typeface="Arial Unicode MS"/>
-                <a:cs typeface="Arial Unicode MS"/>
-              </a:rPr>
-              <a:t>綠框</a:t>
-            </a:r>
-            <a:r>
-              <a:rPr sz="1050" lang="zh-TW" dirty="0">
-                <a:solidFill>
-                  <a:srgbClr val="000000"/>
-                </a:solidFill>
-                <a:latin typeface="Arial Unicode MS"/>
-                <a:ea typeface="Arial Unicode MS"/>
-                <a:cs typeface="Arial Unicode MS"/>
-              </a:rPr>
-              <a:t>，是框裡至少有一個雷達點的：路邊停的那幾台車，框裡都有紅圈。</a:t>
-            </a:r>
-            <a:r>
-              <a:rPr sz="1050" b="1" lang="zh-TW" dirty="0">
-                <a:solidFill>
-                  <a:srgbClr val="000000"/>
-                </a:solidFill>
-                <a:latin typeface="Arial Unicode MS"/>
-                <a:ea typeface="Arial Unicode MS"/>
-                <a:cs typeface="Arial Unicode MS"/>
-              </a:rPr>
-              <a:t>黃框</a:t>
-            </a:r>
-            <a:r>
-              <a:rPr sz="1050" lang="zh-TW" dirty="0">
-                <a:solidFill>
-                  <a:srgbClr val="000000"/>
-                </a:solidFill>
-                <a:latin typeface="Arial Unicode MS"/>
-                <a:ea typeface="Arial Unicode MS"/>
-                <a:cs typeface="Arial Unicode MS"/>
-              </a:rPr>
-              <a:t>，是一個雷達點都沒有的：四個行人，和好幾台遠處的車，大多在四十五公尺以外。這跟上一節那張統計表一樣：雷達抓得到近處的車，抓不太到人，車子一遠也開始漏。
+              <a:rPr sz="900" lang="zh-TW" dirty="0">
+                <a:solidFill>
+                  <a:srgbClr val="000000"/>
+                </a:solidFill>
+                <a:latin typeface="Arial Unicode MS"/>
+                <a:ea typeface="Arial Unicode MS"/>
+                <a:cs typeface="Arial Unicode MS"/>
+              </a:rPr>
+              <a:t>先說明左圖簡化了什麼。真正的後期融合，雷達會先把打在同一台車上的幾個點，整理成</a:t>
+            </a:r>
+            <a:r>
+              <a:rPr sz="900" b="1" lang="zh-TW" dirty="0">
+                <a:solidFill>
+                  <a:srgbClr val="000000"/>
+                </a:solidFill>
+                <a:latin typeface="Arial Unicode MS"/>
+                <a:ea typeface="Arial Unicode MS"/>
+                <a:cs typeface="Arial Unicode MS"/>
+              </a:rPr>
+              <a:t>一個目標</a:t>
+            </a:r>
+            <a:r>
+              <a:rPr sz="900" lang="zh-TW" dirty="0">
+                <a:solidFill>
+                  <a:srgbClr val="000000"/>
+                </a:solidFill>
+                <a:latin typeface="Arial Unicode MS"/>
+                <a:ea typeface="Arial Unicode MS"/>
+                <a:cs typeface="Arial Unicode MS"/>
+              </a:rPr>
+              <a:t>，例如「二十公尺、時速三十」；相機也先自己找出框。最後才是目標對框。這張圖為了讓大家看到原料，直接畫雷達點，框也是人工標註的，不是相機自己找的。雷達點落在哪個框裡，是雷達把點整理成目標之前的原料；等一下影片裡的小白方塊，就是整理好的目標。
 </a:t>
             </a:r>
           </a:p>
@@ -6291,41 +6313,63 @@
                 <a:spcPts val="0"/>
               </a:spcBef>
               <a:spcAft>
-                <a:spcPts val="175"/>
+                <a:spcPts val="150"/>
               </a:spcAft>
             </a:pPr>
             <a:r>
-              <a:rPr sz="1050" lang="zh-TW" dirty="0">
-                <a:solidFill>
-                  <a:srgbClr val="000000"/>
-                </a:solidFill>
-                <a:latin typeface="Arial Unicode MS"/>
-                <a:ea typeface="Arial Unicode MS"/>
-                <a:cs typeface="Arial Unicode MS"/>
-              </a:rPr>
-              <a:t>再看路的右邊，有一長排紅圈，排在人行道旁邊，沒有任何框。那多半是路邊的東西，可能是欄杆、樹、號誌桿。這些點不屬於任何一台標註的物體，對應的時候要</a:t>
-            </a:r>
-            <a:r>
-              <a:rPr sz="1050" b="1" lang="zh-TW" dirty="0">
-                <a:solidFill>
-                  <a:srgbClr val="000000"/>
-                </a:solidFill>
-                <a:latin typeface="Arial Unicode MS"/>
-                <a:ea typeface="Arial Unicode MS"/>
-                <a:cs typeface="Arial Unicode MS"/>
-              </a:rPr>
-              <a:t>正確地丟掉</a:t>
-            </a:r>
-            <a:r>
-              <a:rPr sz="1050" lang="zh-TW" dirty="0">
-                <a:solidFill>
-                  <a:srgbClr val="000000"/>
-                </a:solidFill>
-                <a:latin typeface="Arial Unicode MS"/>
-                <a:ea typeface="Arial Unicode MS"/>
-                <a:cs typeface="Arial Unicode MS"/>
-              </a:rPr>
-              <a:t>，不然就變成上一節講的幽靈煞車。
+              <a:rPr sz="900" lang="zh-TW" dirty="0">
+                <a:solidFill>
+                  <a:srgbClr val="000000"/>
+                </a:solidFill>
+                <a:latin typeface="Arial Unicode MS"/>
+                <a:ea typeface="Arial Unicode MS"/>
+                <a:cs typeface="Arial Unicode MS"/>
+              </a:rPr>
+              <a:t>看左圖，波士頓的一條街。框是官方標註的物體，紅圈是雷達點。</a:t>
+            </a:r>
+            <a:r>
+              <a:rPr sz="900" b="1" lang="zh-TW" dirty="0">
+                <a:solidFill>
+                  <a:srgbClr val="000000"/>
+                </a:solidFill>
+                <a:latin typeface="Arial Unicode MS"/>
+                <a:ea typeface="Arial Unicode MS"/>
+                <a:cs typeface="Arial Unicode MS"/>
+              </a:rPr>
+              <a:t>綠框</a:t>
+            </a:r>
+            <a:r>
+              <a:rPr sz="900" lang="zh-TW" dirty="0">
+                <a:solidFill>
+                  <a:srgbClr val="000000"/>
+                </a:solidFill>
+                <a:latin typeface="Arial Unicode MS"/>
+                <a:ea typeface="Arial Unicode MS"/>
+                <a:cs typeface="Arial Unicode MS"/>
+              </a:rPr>
+              <a:t>，是框裡至少有一個雷達點的：路邊停的那幾台車，框裡都有紅圈。</a:t>
+            </a:r>
+            <a:r>
+              <a:rPr sz="900" b="1" lang="zh-TW" dirty="0">
+                <a:solidFill>
+                  <a:srgbClr val="000000"/>
+                </a:solidFill>
+                <a:latin typeface="Arial Unicode MS"/>
+                <a:ea typeface="Arial Unicode MS"/>
+                <a:cs typeface="Arial Unicode MS"/>
+              </a:rPr>
+              <a:t>黃框</a:t>
+            </a:r>
+            <a:r>
+              <a:rPr sz="900" lang="zh-TW" dirty="0">
+                <a:solidFill>
+                  <a:srgbClr val="000000"/>
+                </a:solidFill>
+                <a:latin typeface="Arial Unicode MS"/>
+                <a:ea typeface="Arial Unicode MS"/>
+                <a:cs typeface="Arial Unicode MS"/>
+              </a:rPr>
+              <a:t>，是一個雷達點都沒有的：四個行人，和好幾台遠處的車，大多在四十五公尺以外。這跟上一節那張統計表一樣：雷達抓得到近處的車，抓不太到人，車子一遠也開始漏。
 </a:t>
             </a:r>
           </a:p>
@@ -6335,63 +6379,41 @@
                 <a:spcPts val="0"/>
               </a:spcBef>
               <a:spcAft>
-                <a:spcPts val="175"/>
+                <a:spcPts val="150"/>
               </a:spcAft>
             </a:pPr>
             <a:r>
-              <a:rPr sz="1050" lang="zh-TW" dirty="0">
-                <a:solidFill>
-                  <a:srgbClr val="000000"/>
-                </a:solidFill>
-                <a:latin typeface="Arial Unicode MS"/>
-                <a:ea typeface="Arial Unicode MS"/>
-                <a:cs typeface="Arial Unicode MS"/>
-              </a:rPr>
-              <a:t>怎麼對？最簡單的就是看</a:t>
-            </a:r>
-            <a:r>
-              <a:rPr sz="1050" b="1" lang="zh-TW" dirty="0">
-                <a:solidFill>
-                  <a:srgbClr val="000000"/>
-                </a:solidFill>
-                <a:latin typeface="Arial Unicode MS"/>
-                <a:ea typeface="Arial Unicode MS"/>
-                <a:cs typeface="Arial Unicode MS"/>
-              </a:rPr>
-              <a:t>位置</a:t>
-            </a:r>
-            <a:r>
-              <a:rPr sz="1050" lang="zh-TW" dirty="0">
-                <a:solidFill>
-                  <a:srgbClr val="000000"/>
-                </a:solidFill>
-                <a:latin typeface="Arial Unicode MS"/>
-                <a:ea typeface="Arial Unicode MS"/>
-                <a:cs typeface="Arial Unicode MS"/>
-              </a:rPr>
-              <a:t>：雷達點落在哪個框附近，就算它的。再加上</a:t>
-            </a:r>
-            <a:r>
-              <a:rPr sz="1050" b="1" lang="zh-TW" dirty="0">
-                <a:solidFill>
-                  <a:srgbClr val="000000"/>
-                </a:solidFill>
-                <a:latin typeface="Arial Unicode MS"/>
-                <a:ea typeface="Arial Unicode MS"/>
-                <a:cs typeface="Arial Unicode MS"/>
-              </a:rPr>
-              <a:t>速度</a:t>
-            </a:r>
-            <a:r>
-              <a:rPr sz="1050" lang="zh-TW" dirty="0">
-                <a:solidFill>
-                  <a:srgbClr val="000000"/>
-                </a:solidFill>
-                <a:latin typeface="Arial Unicode MS"/>
-                <a:ea typeface="Arial Unicode MS"/>
-                <a:cs typeface="Arial Unicode MS"/>
-              </a:rPr>
-              <a:t>：雷達量得到速度，一個靜止的點，不會是一台正在開的車。
+              <a:rPr sz="900" lang="zh-TW" dirty="0">
+                <a:solidFill>
+                  <a:srgbClr val="000000"/>
+                </a:solidFill>
+                <a:latin typeface="Arial Unicode MS"/>
+                <a:ea typeface="Arial Unicode MS"/>
+                <a:cs typeface="Arial Unicode MS"/>
+              </a:rPr>
+              <a:t>再看路的右邊，有一長排紅圈，排在人行道旁邊，沒有任何框。那多半是路邊的東西，可能是欄杆、樹、號誌桿。這些點不屬於任何一台標註的物體，對應的時候要</a:t>
+            </a:r>
+            <a:r>
+              <a:rPr sz="900" b="1" lang="zh-TW" dirty="0">
+                <a:solidFill>
+                  <a:srgbClr val="000000"/>
+                </a:solidFill>
+                <a:latin typeface="Arial Unicode MS"/>
+                <a:ea typeface="Arial Unicode MS"/>
+                <a:cs typeface="Arial Unicode MS"/>
+              </a:rPr>
+              <a:t>正確地丟掉</a:t>
+            </a:r>
+            <a:r>
+              <a:rPr sz="900" lang="zh-TW" dirty="0">
+                <a:solidFill>
+                  <a:srgbClr val="000000"/>
+                </a:solidFill>
+                <a:latin typeface="Arial Unicode MS"/>
+                <a:ea typeface="Arial Unicode MS"/>
+                <a:cs typeface="Arial Unicode MS"/>
+              </a:rPr>
+              <a:t>，不然就變成上一節講的幽靈煞車。
 </a:t>
             </a:r>
           </a:p>
@@ -6401,11 +6423,77 @@
                 <a:spcPts val="0"/>
               </a:spcBef>
               <a:spcAft>
-                <a:spcPts val="175"/>
+                <a:spcPts val="150"/>
               </a:spcAft>
             </a:pPr>
             <a:r>
-              <a:rPr sz="1050" lang="zh-TW" dirty="0">
+              <a:rPr sz="900" lang="zh-TW" dirty="0">
+                <a:solidFill>
+                  <a:srgbClr val="000000"/>
+                </a:solidFill>
+                <a:latin typeface="Arial Unicode MS"/>
+                <a:ea typeface="Arial Unicode MS"/>
+                <a:cs typeface="Arial Unicode MS"/>
+              </a:rPr>
+              <a:t>怎麼對？最簡單的就是看</a:t>
+            </a:r>
+            <a:r>
+              <a:rPr sz="900" b="1" lang="zh-TW" dirty="0">
+                <a:solidFill>
+                  <a:srgbClr val="000000"/>
+                </a:solidFill>
+                <a:latin typeface="Arial Unicode MS"/>
+                <a:ea typeface="Arial Unicode MS"/>
+                <a:cs typeface="Arial Unicode MS"/>
+              </a:rPr>
+              <a:t>位置</a:t>
+            </a:r>
+            <a:r>
+              <a:rPr sz="900" lang="zh-TW" dirty="0">
+                <a:solidFill>
+                  <a:srgbClr val="000000"/>
+                </a:solidFill>
+                <a:latin typeface="Arial Unicode MS"/>
+                <a:ea typeface="Arial Unicode MS"/>
+                <a:cs typeface="Arial Unicode MS"/>
+              </a:rPr>
+              <a:t>：雷達的目標落在哪個框附近，就算它的。再加上</a:t>
+            </a:r>
+            <a:r>
+              <a:rPr sz="900" b="1" lang="zh-TW" dirty="0">
+                <a:solidFill>
+                  <a:srgbClr val="000000"/>
+                </a:solidFill>
+                <a:latin typeface="Arial Unicode MS"/>
+                <a:ea typeface="Arial Unicode MS"/>
+                <a:cs typeface="Arial Unicode MS"/>
+              </a:rPr>
+              <a:t>速度</a:t>
+            </a:r>
+            <a:r>
+              <a:rPr sz="900" lang="zh-TW" dirty="0">
+                <a:solidFill>
+                  <a:srgbClr val="000000"/>
+                </a:solidFill>
+                <a:latin typeface="Arial Unicode MS"/>
+                <a:ea typeface="Arial Unicode MS"/>
+                <a:cs typeface="Arial Unicode MS"/>
+              </a:rPr>
+              <a:t>：雷達量得到速度，一個靜止的目標，不會是一台正在開的車。
+</a:t>
+            </a:r>
+          </a:p>
+          <a:p>
+            <a:pPr algn="l">
+              <a:spcBef>
+                <a:spcPts val="0"/>
+              </a:spcBef>
+              <a:spcAft>
+                <a:spcPts val="150"/>
+              </a:spcAft>
+            </a:pPr>
+            <a:r>
+              <a:rPr sz="900" lang="zh-TW" dirty="0">
                 <a:solidFill>
                   <a:srgbClr val="000000"/>
                 </a:solidFill>
@@ -6416,7 +6504,7 @@
               <a:t>看一支影片，NVIDIA 做自駕晶片的團隊。</a:t>
             </a:r>
             <a:r>
-              <a:rPr sz="1050" b="1" lang="zh-TW" dirty="0">
+              <a:rPr sz="900" b="1" lang="zh-TW" dirty="0">
                 <a:solidFill>
                   <a:srgbClr val="000000"/>
                 </a:solidFill>
@@ -6427,7 +6515,7 @@
               <a:t>從 0:42 播到 1:30。</a:t>
             </a:r>
             <a:r>
-              <a:rPr sz="1050" lang="zh-TW" dirty="0">
+              <a:rPr sz="900" lang="zh-TW" dirty="0">
                 <a:solidFill>
                   <a:srgbClr val="000000"/>
                 </a:solidFill>
@@ -6438,7 +6526,7 @@
               <a:t>英文，我邊播邊講。畫面是車子周圍幾台相機拼起來的；</a:t>
             </a:r>
             <a:r>
-              <a:rPr sz="1050" b="1" lang="zh-TW" dirty="0">
+              <a:rPr sz="900" b="1" lang="zh-TW" dirty="0">
                 <a:solidFill>
                   <a:srgbClr val="000000"/>
                 </a:solidFill>
@@ -6449,7 +6537,7 @@
               <a:t>0:47 小白方塊是雷達追蹤到的目標，橘色的線是它走過的路</a:t>
             </a:r>
             <a:r>
-              <a:rPr sz="1050" lang="zh-TW" dirty="0">
+              <a:rPr sz="900" lang="zh-TW" dirty="0">
                 <a:solidFill>
                   <a:srgbClr val="000000"/>
                 </a:solidFill>
@@ -6460,7 +6548,7 @@
               <a:t>。</a:t>
             </a:r>
             <a:r>
-              <a:rPr sz="1050" b="1" lang="zh-TW" dirty="0">
+              <a:rPr sz="900" b="1" lang="zh-TW" dirty="0">
                 <a:solidFill>
                   <a:srgbClr val="000000"/>
                 </a:solidFill>
@@ -6471,7 +6559,7 @@
               <a:t>0:52</a:t>
             </a:r>
             <a:r>
-              <a:rPr sz="1050" lang="zh-TW" dirty="0">
+              <a:rPr sz="900" lang="zh-TW" dirty="0">
                 <a:solidFill>
                   <a:srgbClr val="000000"/>
                 </a:solidFill>
@@ -6482,7 +6570,7 @@
               <a:t> 旁白說：相機框出來的物體，和雷達的目標對上之後，小方塊會變成綠色。</a:t>
             </a:r>
             <a:r>
-              <a:rPr sz="1050" b="1" lang="zh-TW" dirty="0">
+              <a:rPr sz="900" b="1" lang="zh-TW" dirty="0">
                 <a:solidFill>
                   <a:srgbClr val="000000"/>
                 </a:solidFill>
@@ -6493,7 +6581,7 @@
               <a:t>0:58</a:t>
             </a:r>
             <a:r>
-              <a:rPr sz="1050" lang="zh-TW" dirty="0">
+              <a:rPr sz="900" lang="zh-TW" dirty="0">
                 <a:solidFill>
                   <a:srgbClr val="000000"/>
                 </a:solidFill>
@@ -6504,7 +6592,7 @@
               <a:t> 旁白講了融合的好處：位置、速度、加速度，都變得更準、更可靠。</a:t>
             </a:r>
             <a:r>
-              <a:rPr sz="1050" b="1" lang="zh-TW" dirty="0">
+              <a:rPr sz="900" b="1" lang="zh-TW" dirty="0">
                 <a:solidFill>
                   <a:srgbClr val="000000"/>
                 </a:solidFill>
@@ -6515,7 +6603,7 @@
               <a:t>1:10</a:t>
             </a:r>
             <a:r>
-              <a:rPr sz="1050" lang="zh-TW" dirty="0">
+              <a:rPr sz="900" lang="zh-TW" dirty="0">
                 <a:solidFill>
                   <a:srgbClr val="000000"/>
                 </a:solidFill>
@@ -17859,7 +17947,7 @@
                 <a:ea typeface="Arial" pitchFamily="34" charset="-122"/>
                 <a:cs typeface="Arial" pitchFamily="34" charset="-120"/>
               </a:rPr>
-              <a:t>Ghép đôi: điểm radar nào thuộc về hộp nào? Dựa vào vị trí và tốc độ</a:t>
+              <a:t>Mục tiêu radar đi với hộp camera nào? Xem vị trí và tốc độ</a:t>
             </a:r>
             <a:endParaRPr lang="en-US" sz="2300" dirty="0"/>
           </a:p>
@@ -17879,7 +17967,7 @@
                 <a:ea typeface="微軟正黑體" pitchFamily="34" charset="-122"/>
                 <a:cs typeface="微軟正黑體" pitchFamily="34" charset="-120"/>
               </a:rPr>
-              <a:t>對應：哪一個雷達點，屬於哪一個框？看位置，也看速度</a:t>
+              <a:t>對應：雷達的目標，配哪一個相機的框？看位置，也看速度</a:t>
             </a:r>
             <a:endParaRPr lang="en-US" sz="2300" dirty="0"/>
           </a:p>

</xml_diff>